<commit_message>
docs: segunda parte con 13 casos, gráficas de cobertura, niveles y tiempos, y capturas del sistema en ejecución
</commit_message>
<xml_diff>
--- a/docs/Segunda parte/Diagramas - Segunda parte.pptx
+++ b/docs/Segunda parte/Diagramas - Segunda parte.pptx
@@ -12,6 +12,9 @@
     <p:sldId id="260" r:id="rId11"/>
     <p:sldId id="261" r:id="rId12"/>
     <p:sldId id="262" r:id="rId13"/>
+    <p:sldId id="263" r:id="rId14"/>
+    <p:sldId id="264" r:id="rId15"/>
+    <p:sldId id="265" r:id="rId16"/>
   </p:sldIdLst>
   <p:sldSz cx="12191695" cy="6858000" type="screen4x3"/>
   <p:notesSz cx="6858000" cy="9144000"/>
@@ -131,7 +134,7 @@
               <c:strCache>
                 <c:ptCount val="1"/>
                 <c:pt idx="0">
-                  <c:v>Aprobación</c:v>
+                  <c:v>Serie</c:v>
                 </c:pt>
               </c:strCache>
             </c:strRef>
@@ -165,16 +168,16 @@
             <c:numRef>
               <c:f>Sheet1!$B$2:$B$5</c:f>
               <c:numCache>
-                <c:formatCode>0 %</c:formatCode>
+                <c:formatCode>0.0 %</c:formatCode>
                 <c:ptCount val="4"/>
                 <c:pt idx="0">
                   <c:v>1.0</c:v>
                 </c:pt>
                 <c:pt idx="1">
-                  <c:v>0.7</c:v>
+                  <c:v>0.7692307692307693</c:v>
                 </c:pt>
                 <c:pt idx="2">
-                  <c:v>0.9</c:v>
+                  <c:v>0.9230769230769231</c:v>
                 </c:pt>
                 <c:pt idx="3">
                   <c:v>1.0</c:v>
@@ -184,7 +187,7 @@
           </c:val>
         </c:ser>
         <c:dLbls>
-          <c:numFmt formatCode="0 %" sourceLinked="0"/>
+          <c:numFmt formatCode="0.0 %" sourceLinked="0"/>
           <c:txPr>
             <a:bodyPr/>
             <a:lstStyle/>
@@ -234,7 +237,7 @@
       <c:valAx>
         <c:axId val="-2113994440"/>
         <c:scaling>
-          <c:max val="1.0"/>
+          <c:max val="1.12"/>
           <c:min val="0.0"/>
         </c:scaling>
         <c:delete val="0"/>
@@ -260,6 +263,515 @@
         <c:crossAx val="-2068027336"/>
         <c:crosses val="autoZero"/>
         <c:majorUnit val="0.25"/>
+      </c:valAx>
+    </c:plotArea>
+    <c:dispBlanksAs val="gap"/>
+  </c:chart>
+  <c:txPr>
+    <a:bodyPr/>
+    <a:lstStyle/>
+    <a:p>
+      <a:pPr>
+        <a:defRPr sz="1300">
+          <a:latin typeface="Calibri"/>
+        </a:defRPr>
+      </a:pPr>
+      <a:endParaRPr lang="en-US"/>
+    </a:p>
+  </c:txPr>
+  <c:externalData r:id="rId1">
+    <c:autoUpdate val="0"/>
+  </c:externalData>
+</c:chartSpace>
+</file>
+
+<file path=ppt/charts/chart2.xml><?xml version="1.0" encoding="utf-8"?>
+<c:chartSpace xmlns:c="http://schemas.openxmlformats.org/drawingml/2006/chart" xmlns:a="http://schemas.openxmlformats.org/drawingml/2006/main" xmlns:r="http://schemas.openxmlformats.org/officeDocument/2006/relationships">
+  <c:date1904 val="0"/>
+  <c:chart>
+    <c:autoTitleDeleted val="1"/>
+    <c:plotArea>
+      <c:barChart>
+        <c:barDir val="col"/>
+        <c:grouping val="clustered"/>
+        <c:ser>
+          <c:idx val="0"/>
+          <c:order val="0"/>
+          <c:tx>
+            <c:strRef>
+              <c:f>Sheet1!$B$1</c:f>
+              <c:strCache>
+                <c:ptCount val="1"/>
+                <c:pt idx="0">
+                  <c:v>Serie</c:v>
+                </c:pt>
+              </c:strCache>
+            </c:strRef>
+          </c:tx>
+          <c:spPr>
+            <a:solidFill>
+              <a:srgbClr val="1F4E8C"/>
+            </a:solidFill>
+          </c:spPr>
+          <c:cat>
+            <c:strRef>
+              <c:f>Sheet1!$A$2:$A$5</c:f>
+              <c:strCache>
+                <c:ptCount val="4"/>
+                <c:pt idx="0">
+                  <c:v>Unitaria</c:v>
+                </c:pt>
+                <c:pt idx="1">
+                  <c:v>Integración</c:v>
+                </c:pt>
+                <c:pt idx="2">
+                  <c:v>Sistema</c:v>
+                </c:pt>
+                <c:pt idx="3">
+                  <c:v>Aceptación</c:v>
+                </c:pt>
+              </c:strCache>
+            </c:strRef>
+          </c:cat>
+          <c:val>
+            <c:numRef>
+              <c:f>Sheet1!$B$2:$B$5</c:f>
+              <c:numCache>
+                <c:formatCode>0</c:formatCode>
+                <c:ptCount val="4"/>
+                <c:pt idx="0">
+                  <c:v>5</c:v>
+                </c:pt>
+                <c:pt idx="1">
+                  <c:v>3</c:v>
+                </c:pt>
+                <c:pt idx="2">
+                  <c:v>3</c:v>
+                </c:pt>
+                <c:pt idx="3">
+                  <c:v>2</c:v>
+                </c:pt>
+              </c:numCache>
+            </c:numRef>
+          </c:val>
+        </c:ser>
+        <c:dLbls>
+          <c:numFmt formatCode="0" sourceLinked="0"/>
+          <c:txPr>
+            <a:bodyPr/>
+            <a:lstStyle/>
+            <a:p>
+              <a:pPr>
+                <a:defRPr sz="1400" b="1"/>
+              </a:pPr>
+            </a:p>
+          </c:txPr>
+          <c:dLblPos val="outEnd"/>
+          <c:showLegendKey val="0"/>
+          <c:showVal val="1"/>
+          <c:showCatName val="0"/>
+          <c:showSerName val="0"/>
+          <c:showPercent val="0"/>
+          <c:showBubbleSize val="0"/>
+          <c:showLeaderLines val="1"/>
+        </c:dLbls>
+        <c:gapWidth val="90"/>
+        <c:axId val="-2068027336"/>
+        <c:axId val="-2113994440"/>
+      </c:barChart>
+      <c:catAx>
+        <c:axId val="-2068027336"/>
+        <c:scaling>
+          <c:orientation val="minMax"/>
+        </c:scaling>
+        <c:delete val="0"/>
+        <c:axPos val="b"/>
+        <c:majorTickMark val="out"/>
+        <c:minorTickMark val="none"/>
+        <c:tickLblPos val="nextTo"/>
+        <c:spPr>
+          <a:ln>
+            <a:solidFill>
+              <a:srgbClr val="9AA1AD"/>
+            </a:solidFill>
+          </a:ln>
+        </c:spPr>
+        <c:crossAx val="-2113994440"/>
+        <c:crosses val="autoZero"/>
+        <c:auto val="1"/>
+        <c:lblAlgn val="ctr"/>
+        <c:lblOffset val="100"/>
+        <c:noMultiLvlLbl val="0"/>
+      </c:catAx>
+      <c:valAx>
+        <c:axId val="-2113994440"/>
+        <c:scaling>
+          <c:min val="0.0"/>
+        </c:scaling>
+        <c:delete val="0"/>
+        <c:axPos val="l"/>
+        <c:majorGridlines>
+          <c:spPr>
+            <a:ln>
+              <a:solidFill>
+                <a:srgbClr val="E3E6EB"/>
+              </a:solidFill>
+            </a:ln>
+          </c:spPr>
+        </c:majorGridlines>
+        <c:numFmt formatCode="0" sourceLinked="0"/>
+        <c:majorTickMark val="out"/>
+        <c:minorTickMark val="none"/>
+        <c:tickLblPos val="nextTo"/>
+        <c:spPr>
+          <a:ln>
+            <a:noFill/>
+          </a:ln>
+        </c:spPr>
+        <c:crossAx val="-2068027336"/>
+        <c:crosses val="autoZero"/>
+        <c:majorUnit val="1.0"/>
+      </c:valAx>
+    </c:plotArea>
+    <c:dispBlanksAs val="gap"/>
+  </c:chart>
+  <c:txPr>
+    <a:bodyPr/>
+    <a:lstStyle/>
+    <a:p>
+      <a:pPr>
+        <a:defRPr sz="1300">
+          <a:latin typeface="Calibri"/>
+        </a:defRPr>
+      </a:pPr>
+      <a:endParaRPr lang="en-US"/>
+    </a:p>
+  </c:txPr>
+  <c:externalData r:id="rId1">
+    <c:autoUpdate val="0"/>
+  </c:externalData>
+</c:chartSpace>
+</file>
+
+<file path=ppt/charts/chart3.xml><?xml version="1.0" encoding="utf-8"?>
+<c:chartSpace xmlns:c="http://schemas.openxmlformats.org/drawingml/2006/chart" xmlns:a="http://schemas.openxmlformats.org/drawingml/2006/main" xmlns:r="http://schemas.openxmlformats.org/officeDocument/2006/relationships">
+  <c:date1904 val="0"/>
+  <c:chart>
+    <c:autoTitleDeleted val="1"/>
+    <c:plotArea>
+      <c:barChart>
+        <c:barDir val="bar"/>
+        <c:grouping val="clustered"/>
+        <c:ser>
+          <c:idx val="0"/>
+          <c:order val="0"/>
+          <c:tx>
+            <c:strRef>
+              <c:f>Sheet1!$B$1</c:f>
+              <c:strCache>
+                <c:ptCount val="1"/>
+                <c:pt idx="0">
+                  <c:v>Serie</c:v>
+                </c:pt>
+              </c:strCache>
+            </c:strRef>
+          </c:tx>
+          <c:spPr>
+            <a:solidFill>
+              <a:srgbClr val="1F4E8C"/>
+            </a:solidFill>
+          </c:spPr>
+          <c:cat>
+            <c:strRef>
+              <c:f>Sheet1!$A$2:$A$6</c:f>
+              <c:strCache>
+                <c:ptCount val="5"/>
+                <c:pt idx="0">
+                  <c:v>RF-01 · Registrar productos</c:v>
+                </c:pt>
+                <c:pt idx="1">
+                  <c:v>RF-02 · Consultar existencias</c:v>
+                </c:pt>
+                <c:pt idx="2">
+                  <c:v>RF-03 · Registrar ventas</c:v>
+                </c:pt>
+                <c:pt idx="3">
+                  <c:v>RF-04 · Registrar entradas</c:v>
+                </c:pt>
+                <c:pt idx="4">
+                  <c:v>RF-05 · Reporte y resurtido</c:v>
+                </c:pt>
+              </c:strCache>
+            </c:strRef>
+          </c:cat>
+          <c:val>
+            <c:numRef>
+              <c:f>Sheet1!$B$2:$B$6</c:f>
+              <c:numCache>
+                <c:formatCode>0</c:formatCode>
+                <c:ptCount val="5"/>
+                <c:pt idx="0">
+                  <c:v>4</c:v>
+                </c:pt>
+                <c:pt idx="1">
+                  <c:v>4</c:v>
+                </c:pt>
+                <c:pt idx="2">
+                  <c:v>6</c:v>
+                </c:pt>
+                <c:pt idx="3">
+                  <c:v>2</c:v>
+                </c:pt>
+                <c:pt idx="4">
+                  <c:v>1</c:v>
+                </c:pt>
+              </c:numCache>
+            </c:numRef>
+          </c:val>
+        </c:ser>
+        <c:dLbls>
+          <c:numFmt formatCode="0" sourceLinked="0"/>
+          <c:txPr>
+            <a:bodyPr/>
+            <a:lstStyle/>
+            <a:p>
+              <a:pPr>
+                <a:defRPr sz="1400" b="1"/>
+              </a:pPr>
+            </a:p>
+          </c:txPr>
+          <c:dLblPos val="outEnd"/>
+          <c:showLegendKey val="0"/>
+          <c:showVal val="1"/>
+          <c:showCatName val="0"/>
+          <c:showSerName val="0"/>
+          <c:showPercent val="0"/>
+          <c:showBubbleSize val="0"/>
+          <c:showLeaderLines val="1"/>
+        </c:dLbls>
+        <c:gapWidth val="90"/>
+        <c:axId val="-2068027336"/>
+        <c:axId val="-2113994440"/>
+      </c:barChart>
+      <c:catAx>
+        <c:axId val="-2068027336"/>
+        <c:scaling>
+          <c:orientation val="maxMin"/>
+        </c:scaling>
+        <c:delete val="0"/>
+        <c:axPos val="l"/>
+        <c:majorTickMark val="out"/>
+        <c:minorTickMark val="none"/>
+        <c:tickLblPos val="nextTo"/>
+        <c:spPr>
+          <a:ln>
+            <a:solidFill>
+              <a:srgbClr val="9AA1AD"/>
+            </a:solidFill>
+          </a:ln>
+        </c:spPr>
+        <c:crossAx val="-2113994440"/>
+        <c:crosses val="autoZero"/>
+        <c:auto val="1"/>
+        <c:lblAlgn val="ctr"/>
+        <c:lblOffset val="100"/>
+        <c:noMultiLvlLbl val="0"/>
+      </c:catAx>
+      <c:valAx>
+        <c:axId val="-2113994440"/>
+        <c:scaling>
+          <c:min val="0.0"/>
+        </c:scaling>
+        <c:delete val="0"/>
+        <c:axPos val="b"/>
+        <c:majorGridlines>
+          <c:spPr>
+            <a:ln>
+              <a:solidFill>
+                <a:srgbClr val="E3E6EB"/>
+              </a:solidFill>
+            </a:ln>
+          </c:spPr>
+        </c:majorGridlines>
+        <c:numFmt formatCode="0" sourceLinked="0"/>
+        <c:majorTickMark val="out"/>
+        <c:minorTickMark val="none"/>
+        <c:tickLblPos val="nextTo"/>
+        <c:spPr>
+          <a:ln>
+            <a:noFill/>
+          </a:ln>
+        </c:spPr>
+        <c:crossAx val="-2068027336"/>
+        <c:crosses val="autoZero"/>
+        <c:majorUnit val="1.0"/>
+      </c:valAx>
+    </c:plotArea>
+    <c:dispBlanksAs val="gap"/>
+  </c:chart>
+  <c:txPr>
+    <a:bodyPr/>
+    <a:lstStyle/>
+    <a:p>
+      <a:pPr>
+        <a:defRPr sz="1300">
+          <a:latin typeface="Calibri"/>
+        </a:defRPr>
+      </a:pPr>
+      <a:endParaRPr lang="en-US"/>
+    </a:p>
+  </c:txPr>
+  <c:externalData r:id="rId1">
+    <c:autoUpdate val="0"/>
+  </c:externalData>
+</c:chartSpace>
+</file>
+
+<file path=ppt/charts/chart4.xml><?xml version="1.0" encoding="utf-8"?>
+<c:chartSpace xmlns:c="http://schemas.openxmlformats.org/drawingml/2006/chart" xmlns:a="http://schemas.openxmlformats.org/drawingml/2006/main" xmlns:r="http://schemas.openxmlformats.org/officeDocument/2006/relationships">
+  <c:date1904 val="0"/>
+  <c:chart>
+    <c:autoTitleDeleted val="1"/>
+    <c:plotArea>
+      <c:barChart>
+        <c:barDir val="col"/>
+        <c:grouping val="clustered"/>
+        <c:ser>
+          <c:idx val="0"/>
+          <c:order val="0"/>
+          <c:tx>
+            <c:strRef>
+              <c:f>Sheet1!$B$1</c:f>
+              <c:strCache>
+                <c:ptCount val="1"/>
+                <c:pt idx="0">
+                  <c:v>Serie</c:v>
+                </c:pt>
+              </c:strCache>
+            </c:strRef>
+          </c:tx>
+          <c:spPr>
+            <a:solidFill>
+              <a:srgbClr val="1F4E8C"/>
+            </a:solidFill>
+          </c:spPr>
+          <c:cat>
+            <c:strRef>
+              <c:f>Sheet1!$A$2:$A$5</c:f>
+              <c:strCache>
+                <c:ptCount val="4"/>
+                <c:pt idx="0">
+                  <c:v>Unitaria</c:v>
+                </c:pt>
+                <c:pt idx="1">
+                  <c:v>Integración</c:v>
+                </c:pt>
+                <c:pt idx="2">
+                  <c:v>Sistema</c:v>
+                </c:pt>
+                <c:pt idx="3">
+                  <c:v>Aceptación</c:v>
+                </c:pt>
+              </c:strCache>
+            </c:strRef>
+          </c:cat>
+          <c:val>
+            <c:numRef>
+              <c:f>Sheet1!$B$2:$B$5</c:f>
+              <c:numCache>
+                <c:formatCode>0.000 "s"</c:formatCode>
+                <c:ptCount val="4"/>
+                <c:pt idx="0">
+                  <c:v>0.004</c:v>
+                </c:pt>
+                <c:pt idx="1">
+                  <c:v>0.009</c:v>
+                </c:pt>
+                <c:pt idx="2">
+                  <c:v>2.737</c:v>
+                </c:pt>
+                <c:pt idx="3">
+                  <c:v>1.85</c:v>
+                </c:pt>
+              </c:numCache>
+            </c:numRef>
+          </c:val>
+        </c:ser>
+        <c:dLbls>
+          <c:numFmt formatCode="0.000 &quot;s&quot;" sourceLinked="0"/>
+          <c:txPr>
+            <a:bodyPr/>
+            <a:lstStyle/>
+            <a:p>
+              <a:pPr>
+                <a:defRPr sz="1400" b="1"/>
+              </a:pPr>
+            </a:p>
+          </c:txPr>
+          <c:dLblPos val="outEnd"/>
+          <c:showLegendKey val="0"/>
+          <c:showVal val="1"/>
+          <c:showCatName val="0"/>
+          <c:showSerName val="0"/>
+          <c:showPercent val="0"/>
+          <c:showBubbleSize val="0"/>
+          <c:showLeaderLines val="1"/>
+        </c:dLbls>
+        <c:gapWidth val="90"/>
+        <c:axId val="-2068027336"/>
+        <c:axId val="-2113994440"/>
+      </c:barChart>
+      <c:catAx>
+        <c:axId val="-2068027336"/>
+        <c:scaling>
+          <c:orientation val="minMax"/>
+        </c:scaling>
+        <c:delete val="0"/>
+        <c:axPos val="b"/>
+        <c:majorTickMark val="out"/>
+        <c:minorTickMark val="none"/>
+        <c:tickLblPos val="nextTo"/>
+        <c:spPr>
+          <a:ln>
+            <a:solidFill>
+              <a:srgbClr val="9AA1AD"/>
+            </a:solidFill>
+          </a:ln>
+        </c:spPr>
+        <c:crossAx val="-2113994440"/>
+        <c:crosses val="autoZero"/>
+        <c:auto val="1"/>
+        <c:lblAlgn val="ctr"/>
+        <c:lblOffset val="100"/>
+        <c:noMultiLvlLbl val="0"/>
+      </c:catAx>
+      <c:valAx>
+        <c:axId val="-2113994440"/>
+        <c:scaling>
+          <c:min val="0.0"/>
+        </c:scaling>
+        <c:delete val="0"/>
+        <c:axPos val="l"/>
+        <c:majorGridlines>
+          <c:spPr>
+            <a:ln>
+              <a:solidFill>
+                <a:srgbClr val="E3E6EB"/>
+              </a:solidFill>
+            </a:ln>
+          </c:spPr>
+        </c:majorGridlines>
+        <c:numFmt formatCode="0.000 &quot;s&quot;" sourceLinked="0"/>
+        <c:majorTickMark val="out"/>
+        <c:minorTickMark val="none"/>
+        <c:tickLblPos val="nextTo"/>
+        <c:spPr>
+          <a:ln>
+            <a:noFill/>
+          </a:ln>
+        </c:spPr>
+        <c:crossAx val="-2068027336"/>
+        <c:crosses val="autoZero"/>
       </c:valAx>
     </c:plotArea>
     <c:dispBlanksAs val="gap"/>
@@ -3303,7 +3815,7 @@
                 </a:solidFill>
                 <a:latin typeface="Calibri"/>
               </a:rPr>
-              <a:t>10 casos automatizados con PHPUnit, una carpeta por nivel en tests/</a:t>
+              <a:t>13 casos automatizados con PHPUnit, una carpeta por nivel en tests/</a:t>
             </a:r>
           </a:p>
         </p:txBody>
@@ -3358,7 +3870,7 @@
                 </a:solidFill>
                 <a:latin typeface="Calibri"/>
               </a:rPr>
-              <a:t>Aceptación · CP-09, CP-10</a:t>
+              <a:t>Aceptación · CP-09 y CP-10</a:t>
             </a:r>
           </a:p>
           <a:p>
@@ -3425,7 +3937,7 @@
                 </a:solidFill>
                 <a:latin typeface="Calibri"/>
               </a:rPr>
-              <a:t>Sistema · CP-07, CP-08</a:t>
+              <a:t>Sistema · CP-07, CP-08 y CP-11</a:t>
             </a:r>
           </a:p>
           <a:p>
@@ -3492,7 +4004,7 @@
                 </a:solidFill>
                 <a:latin typeface="Calibri"/>
               </a:rPr>
-              <a:t>Integración · CP-05, CP-06</a:t>
+              <a:t>Integración · CP-05, CP-06 y CP-13</a:t>
             </a:r>
           </a:p>
           <a:p>
@@ -3559,7 +4071,7 @@
                 </a:solidFill>
                 <a:latin typeface="Calibri"/>
               </a:rPr>
-              <a:t>Unitarias · CP-01 a CP-04</a:t>
+              <a:t>Unitarias · CP-01, CP-02, CP-03, CP-04 y CP-12</a:t>
             </a:r>
           </a:p>
           <a:p>
@@ -3606,6 +4118,121 @@
                 <a:latin typeface="Calibri"/>
               </a:rPr>
               <a:t>Más arriba: más cerca de lo que usa la cliente y más lento (≈ 0.9 s por caso). Más abajo: más rápido (milisegundos) y más preciso para ubicar el error.</a:t>
+            </a:r>
+          </a:p>
+        </p:txBody>
+      </p:sp>
+    </p:spTree>
+  </p:cSld>
+  <p:clrMapOvr>
+    <a:masterClrMapping/>
+  </p:clrMapOvr>
+</p:sld>
+</file>
+
+<file path=ppt/slides/slide10.xml><?xml version="1.0" encoding="utf-8"?>
+<p:sld xmlns:a="http://schemas.openxmlformats.org/drawingml/2006/main" xmlns:p="http://schemas.openxmlformats.org/presentationml/2006/main" xmlns:r="http://schemas.openxmlformats.org/officeDocument/2006/relationships">
+  <p:cSld>
+    <p:spTree>
+      <p:nvGrpSpPr>
+        <p:cNvPr id="1" name=""/>
+        <p:cNvGrpSpPr/>
+        <p:nvPr/>
+      </p:nvGrpSpPr>
+      <p:grpSpPr/>
+      <p:sp>
+        <p:nvSpPr>
+          <p:cNvPr id="2" name="TextBox 1"/>
+          <p:cNvSpPr txBox="1"/>
+          <p:nvPr/>
+        </p:nvSpPr>
+        <p:spPr>
+          <a:xfrm>
+            <a:off x="457200" y="274320"/>
+            <a:ext cx="11247120" cy="640080"/>
+          </a:xfrm>
+          <a:prstGeom prst="rect">
+            <a:avLst/>
+          </a:prstGeom>
+          <a:noFill/>
+        </p:spPr>
+        <p:txBody>
+          <a:bodyPr wrap="none">
+            <a:spAutoFit/>
+          </a:bodyPr>
+          <a:lstStyle/>
+          <a:p>
+            <a:r>
+              <a:rPr sz="2600" b="1">
+                <a:solidFill>
+                  <a:srgbClr val="1D2330"/>
+                </a:solidFill>
+                <a:latin typeface="Calibri"/>
+              </a:rPr>
+              <a:t>Tiempo de ejecución por nivel (ronda 1)</a:t>
+            </a:r>
+          </a:p>
+          <a:p>
+            <a:r>
+              <a:rPr sz="1400">
+                <a:solidFill>
+                  <a:srgbClr val="5A6270"/>
+                </a:solidFill>
+                <a:latin typeface="Calibri"/>
+              </a:rPr>
+              <a:t>Suma del tiempo de los casos de cada nivel · total de la ronda: 4.600 s</a:t>
+            </a:r>
+          </a:p>
+        </p:txBody>
+      </p:sp>
+      <p:graphicFrame>
+        <p:nvGraphicFramePr>
+          <p:cNvPr id="3" name="Chart 2"/>
+          <p:cNvGraphicFramePr>
+            <a:graphicFrameLocks noGrp="1"/>
+          </p:cNvGraphicFramePr>
+          <p:nvPr/>
+        </p:nvGraphicFramePr>
+        <p:xfrm>
+          <a:off x="731520" y="1371600"/>
+          <a:ext cx="10698480" cy="4846320"/>
+        </p:xfrm>
+        <a:graphic>
+          <a:graphicData uri="http://schemas.openxmlformats.org/drawingml/2006/chart">
+            <c:chart xmlns:c="http://schemas.openxmlformats.org/drawingml/2006/chart" r:id="rId2"/>
+          </a:graphicData>
+        </a:graphic>
+      </p:graphicFrame>
+      <p:sp>
+        <p:nvSpPr>
+          <p:cNvPr id="4" name="TextBox 3"/>
+          <p:cNvSpPr txBox="1"/>
+          <p:nvPr/>
+        </p:nvSpPr>
+        <p:spPr>
+          <a:xfrm>
+            <a:off x="731520" y="6263640"/>
+            <a:ext cx="10698480" cy="365760"/>
+          </a:xfrm>
+          <a:prstGeom prst="rect">
+            <a:avLst/>
+          </a:prstGeom>
+          <a:noFill/>
+        </p:spPr>
+        <p:txBody>
+          <a:bodyPr wrap="square">
+            <a:spAutoFit/>
+          </a:bodyPr>
+          <a:lstStyle/>
+          <a:p>
+            <a:r>
+              <a:rPr sz="1100" i="0">
+                <a:solidFill>
+                  <a:srgbClr val="5A6270"/>
+                </a:solidFill>
+                <a:latin typeface="Calibri"/>
+              </a:rPr>
+              <a:t>Los casos de sistema y aceptación levantan su propio servidor php -S, por eso tardan cerca de 0.9 s cada uno; los unitarios y de integración tardan milisegundos.</a:t>
             </a:r>
           </a:p>
         </p:txBody>
@@ -5635,7 +6262,7 @@
         </p:nvGraphicFramePr>
         <p:xfrm>
           <a:off x="548640" y="1463040"/>
-          <a:ext cx="11064240" cy="3017520"/>
+          <a:ext cx="11064228" cy="3017520"/>
         </p:xfrm>
         <a:graphic>
           <a:graphicData uri="http://schemas.openxmlformats.org/drawingml/2006/table">
@@ -5645,16 +6272,19 @@
               </a:tblPr>
               <a:tblGrid>
                 <a:gridCol w="3291840"/>
-                <a:gridCol w="777240"/>
-                <a:gridCol w="777240"/>
-                <a:gridCol w="777240"/>
-                <a:gridCol w="777240"/>
-                <a:gridCol w="777240"/>
-                <a:gridCol w="777240"/>
-                <a:gridCol w="777240"/>
-                <a:gridCol w="777240"/>
-                <a:gridCol w="777240"/>
-                <a:gridCol w="777240"/>
+                <a:gridCol w="597876"/>
+                <a:gridCol w="597876"/>
+                <a:gridCol w="597876"/>
+                <a:gridCol w="597876"/>
+                <a:gridCol w="597876"/>
+                <a:gridCol w="597876"/>
+                <a:gridCol w="597876"/>
+                <a:gridCol w="597876"/>
+                <a:gridCol w="597876"/>
+                <a:gridCol w="597876"/>
+                <a:gridCol w="597876"/>
+                <a:gridCol w="597876"/>
+                <a:gridCol w="597876"/>
               </a:tblGrid>
               <a:tr h="502920">
                 <a:tc>
@@ -5664,7 +6294,7 @@
                     <a:p>
                       <a:pPr algn="l"/>
                       <a:r>
-                        <a:rPr sz="1400" b="1">
+                        <a:rPr sz="1300" b="1">
                           <a:solidFill>
                             <a:srgbClr val="FFFFFF"/>
                           </a:solidFill>
@@ -5687,7 +6317,7 @@
                     <a:p>
                       <a:pPr algn="ctr"/>
                       <a:r>
-                        <a:rPr sz="1400" b="1">
+                        <a:rPr sz="1300" b="1">
                           <a:solidFill>
                             <a:srgbClr val="FFFFFF"/>
                           </a:solidFill>
@@ -5710,7 +6340,7 @@
                     <a:p>
                       <a:pPr algn="ctr"/>
                       <a:r>
-                        <a:rPr sz="1400" b="1">
+                        <a:rPr sz="1300" b="1">
                           <a:solidFill>
                             <a:srgbClr val="FFFFFF"/>
                           </a:solidFill>
@@ -5733,7 +6363,7 @@
                     <a:p>
                       <a:pPr algn="ctr"/>
                       <a:r>
-                        <a:rPr sz="1400" b="1">
+                        <a:rPr sz="1300" b="1">
                           <a:solidFill>
                             <a:srgbClr val="FFFFFF"/>
                           </a:solidFill>
@@ -5756,7 +6386,7 @@
                     <a:p>
                       <a:pPr algn="ctr"/>
                       <a:r>
-                        <a:rPr sz="1400" b="1">
+                        <a:rPr sz="1300" b="1">
                           <a:solidFill>
                             <a:srgbClr val="FFFFFF"/>
                           </a:solidFill>
@@ -5779,7 +6409,7 @@
                     <a:p>
                       <a:pPr algn="ctr"/>
                       <a:r>
-                        <a:rPr sz="1400" b="1">
+                        <a:rPr sz="1300" b="1">
                           <a:solidFill>
                             <a:srgbClr val="FFFFFF"/>
                           </a:solidFill>
@@ -5802,7 +6432,7 @@
                     <a:p>
                       <a:pPr algn="ctr"/>
                       <a:r>
-                        <a:rPr sz="1400" b="1">
+                        <a:rPr sz="1300" b="1">
                           <a:solidFill>
                             <a:srgbClr val="FFFFFF"/>
                           </a:solidFill>
@@ -5825,7 +6455,7 @@
                     <a:p>
                       <a:pPr algn="ctr"/>
                       <a:r>
-                        <a:rPr sz="1400" b="1">
+                        <a:rPr sz="1300" b="1">
                           <a:solidFill>
                             <a:srgbClr val="FFFFFF"/>
                           </a:solidFill>
@@ -5848,7 +6478,7 @@
                     <a:p>
                       <a:pPr algn="ctr"/>
                       <a:r>
-                        <a:rPr sz="1400" b="1">
+                        <a:rPr sz="1300" b="1">
                           <a:solidFill>
                             <a:srgbClr val="FFFFFF"/>
                           </a:solidFill>
@@ -5871,7 +6501,7 @@
                     <a:p>
                       <a:pPr algn="ctr"/>
                       <a:r>
-                        <a:rPr sz="1400" b="1">
+                        <a:rPr sz="1300" b="1">
                           <a:solidFill>
                             <a:srgbClr val="FFFFFF"/>
                           </a:solidFill>
@@ -5894,13 +6524,82 @@
                     <a:p>
                       <a:pPr algn="ctr"/>
                       <a:r>
-                        <a:rPr sz="1400" b="1">
+                        <a:rPr sz="1300" b="1">
                           <a:solidFill>
                             <a:srgbClr val="FFFFFF"/>
                           </a:solidFill>
                           <a:latin typeface="Calibri"/>
                         </a:rPr>
                         <a:t>CP-10</a:t>
+                      </a:r>
+                    </a:p>
+                  </a:txBody>
+                  <a:tcPr marL="54864" marR="54864" marT="27432" marB="27432" anchor="ctr">
+                    <a:solidFill>
+                      <a:srgbClr val="1F4E8C"/>
+                    </a:solidFill>
+                  </a:tcPr>
+                </a:tc>
+                <a:tc>
+                  <a:txBody>
+                    <a:bodyPr/>
+                    <a:lstStyle/>
+                    <a:p>
+                      <a:pPr algn="ctr"/>
+                      <a:r>
+                        <a:rPr sz="1300" b="1">
+                          <a:solidFill>
+                            <a:srgbClr val="FFFFFF"/>
+                          </a:solidFill>
+                          <a:latin typeface="Calibri"/>
+                        </a:rPr>
+                        <a:t>CP-11</a:t>
+                      </a:r>
+                    </a:p>
+                  </a:txBody>
+                  <a:tcPr marL="54864" marR="54864" marT="27432" marB="27432" anchor="ctr">
+                    <a:solidFill>
+                      <a:srgbClr val="1F4E8C"/>
+                    </a:solidFill>
+                  </a:tcPr>
+                </a:tc>
+                <a:tc>
+                  <a:txBody>
+                    <a:bodyPr/>
+                    <a:lstStyle/>
+                    <a:p>
+                      <a:pPr algn="ctr"/>
+                      <a:r>
+                        <a:rPr sz="1300" b="1">
+                          <a:solidFill>
+                            <a:srgbClr val="FFFFFF"/>
+                          </a:solidFill>
+                          <a:latin typeface="Calibri"/>
+                        </a:rPr>
+                        <a:t>CP-12</a:t>
+                      </a:r>
+                    </a:p>
+                  </a:txBody>
+                  <a:tcPr marL="54864" marR="54864" marT="27432" marB="27432" anchor="ctr">
+                    <a:solidFill>
+                      <a:srgbClr val="1F4E8C"/>
+                    </a:solidFill>
+                  </a:tcPr>
+                </a:tc>
+                <a:tc>
+                  <a:txBody>
+                    <a:bodyPr/>
+                    <a:lstStyle/>
+                    <a:p>
+                      <a:pPr algn="ctr"/>
+                      <a:r>
+                        <a:rPr sz="1300" b="1">
+                          <a:solidFill>
+                            <a:srgbClr val="FFFFFF"/>
+                          </a:solidFill>
+                          <a:latin typeface="Calibri"/>
+                        </a:rPr>
+                        <a:t>CP-13</a:t>
                       </a:r>
                     </a:p>
                   </a:txBody>
@@ -5919,7 +6618,7 @@
                     <a:p>
                       <a:pPr algn="l"/>
                       <a:r>
-                        <a:rPr sz="1400" b="1">
+                        <a:rPr sz="1300" b="1">
                           <a:solidFill>
                             <a:srgbClr val="1D2330"/>
                           </a:solidFill>
@@ -5942,7 +6641,7 @@
                     <a:p>
                       <a:pPr algn="ctr"/>
                       <a:r>
-                        <a:rPr sz="1400" b="0">
+                        <a:rPr sz="1300" b="0">
                           <a:solidFill>
                             <a:srgbClr val="1D2330"/>
                           </a:solidFill>
@@ -5965,7 +6664,7 @@
                     <a:p>
                       <a:pPr algn="ctr"/>
                       <a:r>
-                        <a:rPr sz="1400" b="0">
+                        <a:rPr sz="1300" b="0">
                           <a:solidFill>
                             <a:srgbClr val="1D2330"/>
                           </a:solidFill>
@@ -5988,7 +6687,7 @@
                     <a:p>
                       <a:pPr algn="ctr"/>
                       <a:r>
-                        <a:rPr sz="1400" b="0">
+                        <a:rPr sz="1300" b="0">
                           <a:solidFill>
                             <a:srgbClr val="1D2330"/>
                           </a:solidFill>
@@ -6011,7 +6710,7 @@
                     <a:p>
                       <a:pPr algn="ctr"/>
                       <a:r>
-                        <a:rPr sz="1400" b="0">
+                        <a:rPr sz="1300" b="0">
                           <a:solidFill>
                             <a:srgbClr val="1D2330"/>
                           </a:solidFill>
@@ -6034,7 +6733,7 @@
                     <a:p>
                       <a:pPr algn="ctr"/>
                       <a:r>
-                        <a:rPr sz="1400" b="0">
+                        <a:rPr sz="1300" b="0">
                           <a:solidFill>
                             <a:srgbClr val="1D2330"/>
                           </a:solidFill>
@@ -6057,7 +6756,7 @@
                     <a:p>
                       <a:pPr algn="ctr"/>
                       <a:r>
-                        <a:rPr sz="1400" b="0">
+                        <a:rPr sz="1300" b="0">
                           <a:solidFill>
                             <a:srgbClr val="1D2330"/>
                           </a:solidFill>
@@ -6080,7 +6779,7 @@
                     <a:p>
                       <a:pPr algn="ctr"/>
                       <a:r>
-                        <a:rPr sz="1400" b="0">
+                        <a:rPr sz="1300" b="0">
                           <a:solidFill>
                             <a:srgbClr val="1D2330"/>
                           </a:solidFill>
@@ -6103,7 +6802,7 @@
                     <a:p>
                       <a:pPr algn="ctr"/>
                       <a:r>
-                        <a:rPr sz="1400" b="0">
+                        <a:rPr sz="1300" b="0">
                           <a:solidFill>
                             <a:srgbClr val="1D2330"/>
                           </a:solidFill>
@@ -6126,7 +6825,7 @@
                     <a:p>
                       <a:pPr algn="ctr"/>
                       <a:r>
-                        <a:rPr sz="1400" b="0">
+                        <a:rPr sz="1300" b="0">
                           <a:solidFill>
                             <a:srgbClr val="1D2330"/>
                           </a:solidFill>
@@ -6149,7 +6848,76 @@
                     <a:p>
                       <a:pPr algn="ctr"/>
                       <a:r>
-                        <a:rPr sz="1400" b="0">
+                        <a:rPr sz="1300" b="0">
+                          <a:solidFill>
+                            <a:srgbClr val="1D2330"/>
+                          </a:solidFill>
+                          <a:latin typeface="Calibri"/>
+                        </a:rPr>
+                        <a:t/>
+                      </a:r>
+                    </a:p>
+                  </a:txBody>
+                  <a:tcPr marL="54864" marR="54864" marT="27432" marB="27432" anchor="ctr">
+                    <a:solidFill>
+                      <a:srgbClr val="FFFFFF"/>
+                    </a:solidFill>
+                  </a:tcPr>
+                </a:tc>
+                <a:tc>
+                  <a:txBody>
+                    <a:bodyPr/>
+                    <a:lstStyle/>
+                    <a:p>
+                      <a:pPr algn="ctr"/>
+                      <a:r>
+                        <a:rPr sz="1300" b="0">
+                          <a:solidFill>
+                            <a:srgbClr val="1D2330"/>
+                          </a:solidFill>
+                          <a:latin typeface="Calibri"/>
+                        </a:rPr>
+                        <a:t/>
+                      </a:r>
+                    </a:p>
+                  </a:txBody>
+                  <a:tcPr marL="54864" marR="54864" marT="27432" marB="27432" anchor="ctr">
+                    <a:solidFill>
+                      <a:srgbClr val="FFFFFF"/>
+                    </a:solidFill>
+                  </a:tcPr>
+                </a:tc>
+                <a:tc>
+                  <a:txBody>
+                    <a:bodyPr/>
+                    <a:lstStyle/>
+                    <a:p>
+                      <a:pPr algn="ctr"/>
+                      <a:r>
+                        <a:rPr sz="1300" b="0">
+                          <a:solidFill>
+                            <a:srgbClr val="1D2330"/>
+                          </a:solidFill>
+                          <a:latin typeface="Calibri"/>
+                        </a:rPr>
+                        <a:t>✔</a:t>
+                      </a:r>
+                    </a:p>
+                  </a:txBody>
+                  <a:tcPr marL="54864" marR="54864" marT="27432" marB="27432" anchor="ctr">
+                    <a:solidFill>
+                      <a:srgbClr val="E8F0FB"/>
+                    </a:solidFill>
+                  </a:tcPr>
+                </a:tc>
+                <a:tc>
+                  <a:txBody>
+                    <a:bodyPr/>
+                    <a:lstStyle/>
+                    <a:p>
+                      <a:pPr algn="ctr"/>
+                      <a:r>
+                        <a:rPr sz="1300" b="0">
                           <a:solidFill>
                             <a:srgbClr val="1D2330"/>
                           </a:solidFill>
@@ -6174,7 +6942,7 @@
                     <a:p>
                       <a:pPr algn="l"/>
                       <a:r>
-                        <a:rPr sz="1400" b="1">
+                        <a:rPr sz="1300" b="1">
                           <a:solidFill>
                             <a:srgbClr val="1D2330"/>
                           </a:solidFill>
@@ -6197,7 +6965,7 @@
                     <a:p>
                       <a:pPr algn="ctr"/>
                       <a:r>
-                        <a:rPr sz="1400" b="0">
+                        <a:rPr sz="1300" b="0">
                           <a:solidFill>
                             <a:srgbClr val="1D2330"/>
                           </a:solidFill>
@@ -6220,7 +6988,7 @@
                     <a:p>
                       <a:pPr algn="ctr"/>
                       <a:r>
-                        <a:rPr sz="1400" b="0">
+                        <a:rPr sz="1300" b="0">
                           <a:solidFill>
                             <a:srgbClr val="1D2330"/>
                           </a:solidFill>
@@ -6243,7 +7011,7 @@
                     <a:p>
                       <a:pPr algn="ctr"/>
                       <a:r>
-                        <a:rPr sz="1400" b="0">
+                        <a:rPr sz="1300" b="0">
                           <a:solidFill>
                             <a:srgbClr val="1D2330"/>
                           </a:solidFill>
@@ -6266,7 +7034,7 @@
                     <a:p>
                       <a:pPr algn="ctr"/>
                       <a:r>
-                        <a:rPr sz="1400" b="0">
+                        <a:rPr sz="1300" b="0">
                           <a:solidFill>
                             <a:srgbClr val="1D2330"/>
                           </a:solidFill>
@@ -6289,7 +7057,7 @@
                     <a:p>
                       <a:pPr algn="ctr"/>
                       <a:r>
-                        <a:rPr sz="1400" b="0">
+                        <a:rPr sz="1300" b="0">
                           <a:solidFill>
                             <a:srgbClr val="1D2330"/>
                           </a:solidFill>
@@ -6312,7 +7080,7 @@
                     <a:p>
                       <a:pPr algn="ctr"/>
                       <a:r>
-                        <a:rPr sz="1400" b="0">
+                        <a:rPr sz="1300" b="0">
                           <a:solidFill>
                             <a:srgbClr val="1D2330"/>
                           </a:solidFill>
@@ -6335,7 +7103,7 @@
                     <a:p>
                       <a:pPr algn="ctr"/>
                       <a:r>
-                        <a:rPr sz="1400" b="0">
+                        <a:rPr sz="1300" b="0">
                           <a:solidFill>
                             <a:srgbClr val="1D2330"/>
                           </a:solidFill>
@@ -6358,7 +7126,7 @@
                     <a:p>
                       <a:pPr algn="ctr"/>
                       <a:r>
-                        <a:rPr sz="1400" b="0">
+                        <a:rPr sz="1300" b="0">
                           <a:solidFill>
                             <a:srgbClr val="1D2330"/>
                           </a:solidFill>
@@ -6381,7 +7149,7 @@
                     <a:p>
                       <a:pPr algn="ctr"/>
                       <a:r>
-                        <a:rPr sz="1400" b="0">
+                        <a:rPr sz="1300" b="0">
                           <a:solidFill>
                             <a:srgbClr val="1D2330"/>
                           </a:solidFill>
@@ -6404,7 +7172,7 @@
                     <a:p>
                       <a:pPr algn="ctr"/>
                       <a:r>
-                        <a:rPr sz="1400" b="0">
+                        <a:rPr sz="1300" b="0">
                           <a:solidFill>
                             <a:srgbClr val="1D2330"/>
                           </a:solidFill>
@@ -6417,6 +7185,75 @@
                   <a:tcPr marL="54864" marR="54864" marT="27432" marB="27432" anchor="ctr">
                     <a:solidFill>
                       <a:srgbClr val="E8F0FB"/>
+                    </a:solidFill>
+                  </a:tcPr>
+                </a:tc>
+                <a:tc>
+                  <a:txBody>
+                    <a:bodyPr/>
+                    <a:lstStyle/>
+                    <a:p>
+                      <a:pPr algn="ctr"/>
+                      <a:r>
+                        <a:rPr sz="1300" b="0">
+                          <a:solidFill>
+                            <a:srgbClr val="1D2330"/>
+                          </a:solidFill>
+                          <a:latin typeface="Calibri"/>
+                        </a:rPr>
+                        <a:t>✔</a:t>
+                      </a:r>
+                    </a:p>
+                  </a:txBody>
+                  <a:tcPr marL="54864" marR="54864" marT="27432" marB="27432" anchor="ctr">
+                    <a:solidFill>
+                      <a:srgbClr val="E8F0FB"/>
+                    </a:solidFill>
+                  </a:tcPr>
+                </a:tc>
+                <a:tc>
+                  <a:txBody>
+                    <a:bodyPr/>
+                    <a:lstStyle/>
+                    <a:p>
+                      <a:pPr algn="ctr"/>
+                      <a:r>
+                        <a:rPr sz="1300" b="0">
+                          <a:solidFill>
+                            <a:srgbClr val="1D2330"/>
+                          </a:solidFill>
+                          <a:latin typeface="Calibri"/>
+                        </a:rPr>
+                        <a:t/>
+                      </a:r>
+                    </a:p>
+                  </a:txBody>
+                  <a:tcPr marL="54864" marR="54864" marT="27432" marB="27432" anchor="ctr">
+                    <a:solidFill>
+                      <a:srgbClr val="F4F5F7"/>
+                    </a:solidFill>
+                  </a:tcPr>
+                </a:tc>
+                <a:tc>
+                  <a:txBody>
+                    <a:bodyPr/>
+                    <a:lstStyle/>
+                    <a:p>
+                      <a:pPr algn="ctr"/>
+                      <a:r>
+                        <a:rPr sz="1300" b="0">
+                          <a:solidFill>
+                            <a:srgbClr val="1D2330"/>
+                          </a:solidFill>
+                          <a:latin typeface="Calibri"/>
+                        </a:rPr>
+                        <a:t/>
+                      </a:r>
+                    </a:p>
+                  </a:txBody>
+                  <a:tcPr marL="54864" marR="54864" marT="27432" marB="27432" anchor="ctr">
+                    <a:solidFill>
+                      <a:srgbClr val="F4F5F7"/>
                     </a:solidFill>
                   </a:tcPr>
                 </a:tc>
@@ -6429,7 +7266,7 @@
                     <a:p>
                       <a:pPr algn="l"/>
                       <a:r>
-                        <a:rPr sz="1400" b="1">
+                        <a:rPr sz="1300" b="1">
                           <a:solidFill>
                             <a:srgbClr val="1D2330"/>
                           </a:solidFill>
@@ -6452,7 +7289,7 @@
                     <a:p>
                       <a:pPr algn="ctr"/>
                       <a:r>
-                        <a:rPr sz="1400" b="0">
+                        <a:rPr sz="1300" b="0">
                           <a:solidFill>
                             <a:srgbClr val="1D2330"/>
                           </a:solidFill>
@@ -6475,7 +7312,7 @@
                     <a:p>
                       <a:pPr algn="ctr"/>
                       <a:r>
-                        <a:rPr sz="1400" b="0">
+                        <a:rPr sz="1300" b="0">
                           <a:solidFill>
                             <a:srgbClr val="1D2330"/>
                           </a:solidFill>
@@ -6498,7 +7335,7 @@
                     <a:p>
                       <a:pPr algn="ctr"/>
                       <a:r>
-                        <a:rPr sz="1400" b="0">
+                        <a:rPr sz="1300" b="0">
                           <a:solidFill>
                             <a:srgbClr val="1D2330"/>
                           </a:solidFill>
@@ -6521,7 +7358,7 @@
                     <a:p>
                       <a:pPr algn="ctr"/>
                       <a:r>
-                        <a:rPr sz="1400" b="0">
+                        <a:rPr sz="1300" b="0">
                           <a:solidFill>
                             <a:srgbClr val="1D2330"/>
                           </a:solidFill>
@@ -6544,7 +7381,7 @@
                     <a:p>
                       <a:pPr algn="ctr"/>
                       <a:r>
-                        <a:rPr sz="1400" b="0">
+                        <a:rPr sz="1300" b="0">
                           <a:solidFill>
                             <a:srgbClr val="1D2330"/>
                           </a:solidFill>
@@ -6567,7 +7404,7 @@
                     <a:p>
                       <a:pPr algn="ctr"/>
                       <a:r>
-                        <a:rPr sz="1400" b="0">
+                        <a:rPr sz="1300" b="0">
                           <a:solidFill>
                             <a:srgbClr val="1D2330"/>
                           </a:solidFill>
@@ -6590,7 +7427,7 @@
                     <a:p>
                       <a:pPr algn="ctr"/>
                       <a:r>
-                        <a:rPr sz="1400" b="0">
+                        <a:rPr sz="1300" b="0">
                           <a:solidFill>
                             <a:srgbClr val="1D2330"/>
                           </a:solidFill>
@@ -6613,7 +7450,7 @@
                     <a:p>
                       <a:pPr algn="ctr"/>
                       <a:r>
-                        <a:rPr sz="1400" b="0">
+                        <a:rPr sz="1300" b="0">
                           <a:solidFill>
                             <a:srgbClr val="1D2330"/>
                           </a:solidFill>
@@ -6636,7 +7473,7 @@
                     <a:p>
                       <a:pPr algn="ctr"/>
                       <a:r>
-                        <a:rPr sz="1400" b="0">
+                        <a:rPr sz="1300" b="0">
                           <a:solidFill>
                             <a:srgbClr val="1D2330"/>
                           </a:solidFill>
@@ -6659,7 +7496,76 @@
                     <a:p>
                       <a:pPr algn="ctr"/>
                       <a:r>
-                        <a:rPr sz="1400" b="0">
+                        <a:rPr sz="1300" b="0">
+                          <a:solidFill>
+                            <a:srgbClr val="1D2330"/>
+                          </a:solidFill>
+                          <a:latin typeface="Calibri"/>
+                        </a:rPr>
+                        <a:t/>
+                      </a:r>
+                    </a:p>
+                  </a:txBody>
+                  <a:tcPr marL="54864" marR="54864" marT="27432" marB="27432" anchor="ctr">
+                    <a:solidFill>
+                      <a:srgbClr val="FFFFFF"/>
+                    </a:solidFill>
+                  </a:tcPr>
+                </a:tc>
+                <a:tc>
+                  <a:txBody>
+                    <a:bodyPr/>
+                    <a:lstStyle/>
+                    <a:p>
+                      <a:pPr algn="ctr"/>
+                      <a:r>
+                        <a:rPr sz="1300" b="0">
+                          <a:solidFill>
+                            <a:srgbClr val="1D2330"/>
+                          </a:solidFill>
+                          <a:latin typeface="Calibri"/>
+                        </a:rPr>
+                        <a:t/>
+                      </a:r>
+                    </a:p>
+                  </a:txBody>
+                  <a:tcPr marL="54864" marR="54864" marT="27432" marB="27432" anchor="ctr">
+                    <a:solidFill>
+                      <a:srgbClr val="FFFFFF"/>
+                    </a:solidFill>
+                  </a:tcPr>
+                </a:tc>
+                <a:tc>
+                  <a:txBody>
+                    <a:bodyPr/>
+                    <a:lstStyle/>
+                    <a:p>
+                      <a:pPr algn="ctr"/>
+                      <a:r>
+                        <a:rPr sz="1300" b="0">
+                          <a:solidFill>
+                            <a:srgbClr val="1D2330"/>
+                          </a:solidFill>
+                          <a:latin typeface="Calibri"/>
+                        </a:rPr>
+                        <a:t/>
+                      </a:r>
+                    </a:p>
+                  </a:txBody>
+                  <a:tcPr marL="54864" marR="54864" marT="27432" marB="27432" anchor="ctr">
+                    <a:solidFill>
+                      <a:srgbClr val="FFFFFF"/>
+                    </a:solidFill>
+                  </a:tcPr>
+                </a:tc>
+                <a:tc>
+                  <a:txBody>
+                    <a:bodyPr/>
+                    <a:lstStyle/>
+                    <a:p>
+                      <a:pPr algn="ctr"/>
+                      <a:r>
+                        <a:rPr sz="1300" b="0">
                           <a:solidFill>
                             <a:srgbClr val="1D2330"/>
                           </a:solidFill>
@@ -6684,7 +7590,7 @@
                     <a:p>
                       <a:pPr algn="l"/>
                       <a:r>
-                        <a:rPr sz="1400" b="1">
+                        <a:rPr sz="1300" b="1">
                           <a:solidFill>
                             <a:srgbClr val="1D2330"/>
                           </a:solidFill>
@@ -6707,7 +7613,7 @@
                     <a:p>
                       <a:pPr algn="ctr"/>
                       <a:r>
-                        <a:rPr sz="1400" b="0">
+                        <a:rPr sz="1300" b="0">
                           <a:solidFill>
                             <a:srgbClr val="1D2330"/>
                           </a:solidFill>
@@ -6730,7 +7636,7 @@
                     <a:p>
                       <a:pPr algn="ctr"/>
                       <a:r>
-                        <a:rPr sz="1400" b="0">
+                        <a:rPr sz="1300" b="0">
                           <a:solidFill>
                             <a:srgbClr val="1D2330"/>
                           </a:solidFill>
@@ -6753,7 +7659,7 @@
                     <a:p>
                       <a:pPr algn="ctr"/>
                       <a:r>
-                        <a:rPr sz="1400" b="0">
+                        <a:rPr sz="1300" b="0">
                           <a:solidFill>
                             <a:srgbClr val="1D2330"/>
                           </a:solidFill>
@@ -6776,7 +7682,7 @@
                     <a:p>
                       <a:pPr algn="ctr"/>
                       <a:r>
-                        <a:rPr sz="1400" b="0">
+                        <a:rPr sz="1300" b="0">
                           <a:solidFill>
                             <a:srgbClr val="1D2330"/>
                           </a:solidFill>
@@ -6799,7 +7705,7 @@
                     <a:p>
                       <a:pPr algn="ctr"/>
                       <a:r>
-                        <a:rPr sz="1400" b="0">
+                        <a:rPr sz="1300" b="0">
                           <a:solidFill>
                             <a:srgbClr val="1D2330"/>
                           </a:solidFill>
@@ -6822,7 +7728,7 @@
                     <a:p>
                       <a:pPr algn="ctr"/>
                       <a:r>
-                        <a:rPr sz="1400" b="0">
+                        <a:rPr sz="1300" b="0">
                           <a:solidFill>
                             <a:srgbClr val="1D2330"/>
                           </a:solidFill>
@@ -6845,7 +7751,7 @@
                     <a:p>
                       <a:pPr algn="ctr"/>
                       <a:r>
-                        <a:rPr sz="1400" b="0">
+                        <a:rPr sz="1300" b="0">
                           <a:solidFill>
                             <a:srgbClr val="1D2330"/>
                           </a:solidFill>
@@ -6868,7 +7774,7 @@
                     <a:p>
                       <a:pPr algn="ctr"/>
                       <a:r>
-                        <a:rPr sz="1400" b="0">
+                        <a:rPr sz="1300" b="0">
                           <a:solidFill>
                             <a:srgbClr val="1D2330"/>
                           </a:solidFill>
@@ -6891,7 +7797,7 @@
                     <a:p>
                       <a:pPr algn="ctr"/>
                       <a:r>
-                        <a:rPr sz="1400" b="0">
+                        <a:rPr sz="1300" b="0">
                           <a:solidFill>
                             <a:srgbClr val="1D2330"/>
                           </a:solidFill>
@@ -6914,7 +7820,76 @@
                     <a:p>
                       <a:pPr algn="ctr"/>
                       <a:r>
-                        <a:rPr sz="1400" b="0">
+                        <a:rPr sz="1300" b="0">
+                          <a:solidFill>
+                            <a:srgbClr val="1D2330"/>
+                          </a:solidFill>
+                          <a:latin typeface="Calibri"/>
+                        </a:rPr>
+                        <a:t>✔</a:t>
+                      </a:r>
+                    </a:p>
+                  </a:txBody>
+                  <a:tcPr marL="54864" marR="54864" marT="27432" marB="27432" anchor="ctr">
+                    <a:solidFill>
+                      <a:srgbClr val="E8F0FB"/>
+                    </a:solidFill>
+                  </a:tcPr>
+                </a:tc>
+                <a:tc>
+                  <a:txBody>
+                    <a:bodyPr/>
+                    <a:lstStyle/>
+                    <a:p>
+                      <a:pPr algn="ctr"/>
+                      <a:r>
+                        <a:rPr sz="1300" b="0">
+                          <a:solidFill>
+                            <a:srgbClr val="1D2330"/>
+                          </a:solidFill>
+                          <a:latin typeface="Calibri"/>
+                        </a:rPr>
+                        <a:t/>
+                      </a:r>
+                    </a:p>
+                  </a:txBody>
+                  <a:tcPr marL="54864" marR="54864" marT="27432" marB="27432" anchor="ctr">
+                    <a:solidFill>
+                      <a:srgbClr val="F4F5F7"/>
+                    </a:solidFill>
+                  </a:tcPr>
+                </a:tc>
+                <a:tc>
+                  <a:txBody>
+                    <a:bodyPr/>
+                    <a:lstStyle/>
+                    <a:p>
+                      <a:pPr algn="ctr"/>
+                      <a:r>
+                        <a:rPr sz="1300" b="0">
+                          <a:solidFill>
+                            <a:srgbClr val="1D2330"/>
+                          </a:solidFill>
+                          <a:latin typeface="Calibri"/>
+                        </a:rPr>
+                        <a:t/>
+                      </a:r>
+                    </a:p>
+                  </a:txBody>
+                  <a:tcPr marL="54864" marR="54864" marT="27432" marB="27432" anchor="ctr">
+                    <a:solidFill>
+                      <a:srgbClr val="F4F5F7"/>
+                    </a:solidFill>
+                  </a:tcPr>
+                </a:tc>
+                <a:tc>
+                  <a:txBody>
+                    <a:bodyPr/>
+                    <a:lstStyle/>
+                    <a:p>
+                      <a:pPr algn="ctr"/>
+                      <a:r>
+                        <a:rPr sz="1300" b="0">
                           <a:solidFill>
                             <a:srgbClr val="1D2330"/>
                           </a:solidFill>
@@ -6939,7 +7914,7 @@
                     <a:p>
                       <a:pPr algn="l"/>
                       <a:r>
-                        <a:rPr sz="1400" b="1">
+                        <a:rPr sz="1300" b="1">
                           <a:solidFill>
                             <a:srgbClr val="1D2330"/>
                           </a:solidFill>
@@ -6962,7 +7937,7 @@
                     <a:p>
                       <a:pPr algn="ctr"/>
                       <a:r>
-                        <a:rPr sz="1400" b="0">
+                        <a:rPr sz="1300" b="0">
                           <a:solidFill>
                             <a:srgbClr val="1D2330"/>
                           </a:solidFill>
@@ -6985,7 +7960,7 @@
                     <a:p>
                       <a:pPr algn="ctr"/>
                       <a:r>
-                        <a:rPr sz="1400" b="0">
+                        <a:rPr sz="1300" b="0">
                           <a:solidFill>
                             <a:srgbClr val="1D2330"/>
                           </a:solidFill>
@@ -7008,7 +7983,7 @@
                     <a:p>
                       <a:pPr algn="ctr"/>
                       <a:r>
-                        <a:rPr sz="1400" b="0">
+                        <a:rPr sz="1300" b="0">
                           <a:solidFill>
                             <a:srgbClr val="1D2330"/>
                           </a:solidFill>
@@ -7031,7 +8006,7 @@
                     <a:p>
                       <a:pPr algn="ctr"/>
                       <a:r>
-                        <a:rPr sz="1400" b="0">
+                        <a:rPr sz="1300" b="0">
                           <a:solidFill>
                             <a:srgbClr val="1D2330"/>
                           </a:solidFill>
@@ -7054,7 +8029,7 @@
                     <a:p>
                       <a:pPr algn="ctr"/>
                       <a:r>
-                        <a:rPr sz="1400" b="0">
+                        <a:rPr sz="1300" b="0">
                           <a:solidFill>
                             <a:srgbClr val="1D2330"/>
                           </a:solidFill>
@@ -7077,7 +8052,7 @@
                     <a:p>
                       <a:pPr algn="ctr"/>
                       <a:r>
-                        <a:rPr sz="1400" b="0">
+                        <a:rPr sz="1300" b="0">
                           <a:solidFill>
                             <a:srgbClr val="1D2330"/>
                           </a:solidFill>
@@ -7100,7 +8075,7 @@
                     <a:p>
                       <a:pPr algn="ctr"/>
                       <a:r>
-                        <a:rPr sz="1400" b="0">
+                        <a:rPr sz="1300" b="0">
                           <a:solidFill>
                             <a:srgbClr val="1D2330"/>
                           </a:solidFill>
@@ -7123,7 +8098,7 @@
                     <a:p>
                       <a:pPr algn="ctr"/>
                       <a:r>
-                        <a:rPr sz="1400" b="0">
+                        <a:rPr sz="1300" b="0">
                           <a:solidFill>
                             <a:srgbClr val="1D2330"/>
                           </a:solidFill>
@@ -7146,7 +8121,7 @@
                     <a:p>
                       <a:pPr algn="ctr"/>
                       <a:r>
-                        <a:rPr sz="1400" b="0">
+                        <a:rPr sz="1300" b="0">
                           <a:solidFill>
                             <a:srgbClr val="1D2330"/>
                           </a:solidFill>
@@ -7169,7 +8144,76 @@
                     <a:p>
                       <a:pPr algn="ctr"/>
                       <a:r>
-                        <a:rPr sz="1400" b="0">
+                        <a:rPr sz="1300" b="0">
+                          <a:solidFill>
+                            <a:srgbClr val="1D2330"/>
+                          </a:solidFill>
+                          <a:latin typeface="Calibri"/>
+                        </a:rPr>
+                        <a:t/>
+                      </a:r>
+                    </a:p>
+                  </a:txBody>
+                  <a:tcPr marL="54864" marR="54864" marT="27432" marB="27432" anchor="ctr">
+                    <a:solidFill>
+                      <a:srgbClr val="FFFFFF"/>
+                    </a:solidFill>
+                  </a:tcPr>
+                </a:tc>
+                <a:tc>
+                  <a:txBody>
+                    <a:bodyPr/>
+                    <a:lstStyle/>
+                    <a:p>
+                      <a:pPr algn="ctr"/>
+                      <a:r>
+                        <a:rPr sz="1300" b="0">
+                          <a:solidFill>
+                            <a:srgbClr val="1D2330"/>
+                          </a:solidFill>
+                          <a:latin typeface="Calibri"/>
+                        </a:rPr>
+                        <a:t/>
+                      </a:r>
+                    </a:p>
+                  </a:txBody>
+                  <a:tcPr marL="54864" marR="54864" marT="27432" marB="27432" anchor="ctr">
+                    <a:solidFill>
+                      <a:srgbClr val="FFFFFF"/>
+                    </a:solidFill>
+                  </a:tcPr>
+                </a:tc>
+                <a:tc>
+                  <a:txBody>
+                    <a:bodyPr/>
+                    <a:lstStyle/>
+                    <a:p>
+                      <a:pPr algn="ctr"/>
+                      <a:r>
+                        <a:rPr sz="1300" b="0">
+                          <a:solidFill>
+                            <a:srgbClr val="1D2330"/>
+                          </a:solidFill>
+                          <a:latin typeface="Calibri"/>
+                        </a:rPr>
+                        <a:t/>
+                      </a:r>
+                    </a:p>
+                  </a:txBody>
+                  <a:tcPr marL="54864" marR="54864" marT="27432" marB="27432" anchor="ctr">
+                    <a:solidFill>
+                      <a:srgbClr val="FFFFFF"/>
+                    </a:solidFill>
+                  </a:tcPr>
+                </a:tc>
+                <a:tc>
+                  <a:txBody>
+                    <a:bodyPr/>
+                    <a:lstStyle/>
+                    <a:p>
+                      <a:pPr algn="ctr"/>
+                      <a:r>
+                        <a:rPr sz="1300" b="0">
                           <a:solidFill>
                             <a:srgbClr val="1D2330"/>
                           </a:solidFill>
@@ -7219,7 +8263,7 @@
                 </a:solidFill>
                 <a:latin typeface="Calibri"/>
               </a:rPr>
-              <a:t>Unitarias: CP-01 a CP-04 · Integración: CP-05 y CP-06 · Sistema: CP-07 y CP-08 · Aceptación: CP-09 y CP-10</a:t>
+              <a:t>Unitaria: CP-01, CP-02, CP-03, CP-04 y CP-12 · Integración: CP-05, CP-06 y CP-13 · Sistema: CP-07, CP-08 y CP-11 · Aceptación: CP-09 y CP-10</a:t>
             </a:r>
           </a:p>
         </p:txBody>
@@ -7334,7 +8378,7 @@
                 </a:solidFill>
                 <a:latin typeface="Calibri"/>
               </a:rPr>
-              <a:t>Ronda 1 · código actual: 10 de 10  ·  Ronda 2 · con DEF-01: 7 de 10  ·  Ronda 3 · con DEF-02: 9 de 10  ·  Ronda 4 · código corregido: 10 de 10</a:t>
+              <a:t>Ronda 1 · código actual: 13 de 13  ·  Ronda 2 · con DEF-01: 10 de 13  ·  Ronda 3 · con DEF-02: 12 de 13  ·  Ronda 4 · código corregido: 13 de 13</a:t>
             </a:r>
           </a:p>
         </p:txBody>
@@ -7721,7 +8765,7 @@
                 </a:solidFill>
                 <a:latin typeface="Calibri"/>
               </a:rPr>
-              <a:t>los 10 casos por niveles</a:t>
+              <a:t>los 13 casos por niveles</a:t>
             </a:r>
           </a:p>
         </p:txBody>
@@ -9349,7 +10393,7 @@
                 </a:solidFill>
                 <a:latin typeface="Calibri"/>
               </a:rPr>
-              <a:t>CP-01 a CP-04</a:t>
+              <a:t>CP-01 a CP-04 y CP-12</a:t>
             </a:r>
           </a:p>
           <a:p>
@@ -9430,7 +10474,7 @@
                 </a:solidFill>
                 <a:latin typeface="Calibri"/>
               </a:rPr>
-              <a:t>CP-05 y CP-06</a:t>
+              <a:t>CP-05, CP-06 y CP-13</a:t>
             </a:r>
           </a:p>
           <a:p>
@@ -9511,7 +10555,7 @@
                 </a:solidFill>
                 <a:latin typeface="Calibri"/>
               </a:rPr>
-              <a:t>CP-07 y CP-08</a:t>
+              <a:t>CP-07, CP-08 y CP-11</a:t>
             </a:r>
           </a:p>
           <a:p>
@@ -10420,6 +11464,236 @@
                 <a:latin typeface="Calibri"/>
               </a:rPr>
               <a:t>concurrency: un push nuevo en la misma rama cancela la ejecución anterior · caché de Composer por versión de PHP · protección de ramas: main y develop solo aceptan PR con todos los checks en verde</a:t>
+            </a:r>
+          </a:p>
+        </p:txBody>
+      </p:sp>
+    </p:spTree>
+  </p:cSld>
+  <p:clrMapOvr>
+    <a:masterClrMapping/>
+  </p:clrMapOvr>
+</p:sld>
+</file>
+
+<file path=ppt/slides/slide8.xml><?xml version="1.0" encoding="utf-8"?>
+<p:sld xmlns:a="http://schemas.openxmlformats.org/drawingml/2006/main" xmlns:p="http://schemas.openxmlformats.org/presentationml/2006/main" xmlns:r="http://schemas.openxmlformats.org/officeDocument/2006/relationships">
+  <p:cSld>
+    <p:spTree>
+      <p:nvGrpSpPr>
+        <p:cNvPr id="1" name=""/>
+        <p:cNvGrpSpPr/>
+        <p:nvPr/>
+      </p:nvGrpSpPr>
+      <p:grpSpPr/>
+      <p:sp>
+        <p:nvSpPr>
+          <p:cNvPr id="2" name="TextBox 1"/>
+          <p:cNvSpPr txBox="1"/>
+          <p:nvPr/>
+        </p:nvSpPr>
+        <p:spPr>
+          <a:xfrm>
+            <a:off x="457200" y="274320"/>
+            <a:ext cx="11247120" cy="640080"/>
+          </a:xfrm>
+          <a:prstGeom prst="rect">
+            <a:avLst/>
+          </a:prstGeom>
+          <a:noFill/>
+        </p:spPr>
+        <p:txBody>
+          <a:bodyPr wrap="none">
+            <a:spAutoFit/>
+          </a:bodyPr>
+          <a:lstStyle/>
+          <a:p>
+            <a:r>
+              <a:rPr sz="2600" b="1">
+                <a:solidFill>
+                  <a:srgbClr val="1D2330"/>
+                </a:solidFill>
+                <a:latin typeface="Calibri"/>
+              </a:rPr>
+              <a:t>Casos de prueba por nivel</a:t>
+            </a:r>
+          </a:p>
+          <a:p>
+            <a:r>
+              <a:rPr sz="1400">
+                <a:solidFill>
+                  <a:srgbClr val="5A6270"/>
+                </a:solidFill>
+                <a:latin typeface="Calibri"/>
+              </a:rPr>
+              <a:t>13 casos en total; cada nivel tiene su propia suite de PHPUnit</a:t>
+            </a:r>
+          </a:p>
+        </p:txBody>
+      </p:sp>
+      <p:graphicFrame>
+        <p:nvGraphicFramePr>
+          <p:cNvPr id="3" name="Chart 2"/>
+          <p:cNvGraphicFramePr>
+            <a:graphicFrameLocks noGrp="1"/>
+          </p:cNvGraphicFramePr>
+          <p:nvPr/>
+        </p:nvGraphicFramePr>
+        <p:xfrm>
+          <a:off x="731520" y="1371600"/>
+          <a:ext cx="10698480" cy="4846320"/>
+        </p:xfrm>
+        <a:graphic>
+          <a:graphicData uri="http://schemas.openxmlformats.org/drawingml/2006/chart">
+            <c:chart xmlns:c="http://schemas.openxmlformats.org/drawingml/2006/chart" r:id="rId2"/>
+          </a:graphicData>
+        </a:graphic>
+      </p:graphicFrame>
+      <p:sp>
+        <p:nvSpPr>
+          <p:cNvPr id="4" name="TextBox 3"/>
+          <p:cNvSpPr txBox="1"/>
+          <p:nvPr/>
+        </p:nvSpPr>
+        <p:spPr>
+          <a:xfrm>
+            <a:off x="731520" y="6263640"/>
+            <a:ext cx="10698480" cy="365760"/>
+          </a:xfrm>
+          <a:prstGeom prst="rect">
+            <a:avLst/>
+          </a:prstGeom>
+          <a:noFill/>
+        </p:spPr>
+        <p:txBody>
+          <a:bodyPr wrap="square">
+            <a:spAutoFit/>
+          </a:bodyPr>
+          <a:lstStyle/>
+          <a:p>
+            <a:r>
+              <a:rPr sz="1100" i="0">
+                <a:solidFill>
+                  <a:srgbClr val="5A6270"/>
+                </a:solidFill>
+                <a:latin typeface="Calibri"/>
+              </a:rPr>
+              <a:t>Unitaria: CP-01, CP-02, CP-03, CP-04 y CP-12  ·  Integración: CP-05, CP-06 y CP-13  ·  Sistema: CP-07, CP-08 y CP-11  ·  Aceptación: CP-09 y CP-10</a:t>
+            </a:r>
+          </a:p>
+        </p:txBody>
+      </p:sp>
+    </p:spTree>
+  </p:cSld>
+  <p:clrMapOvr>
+    <a:masterClrMapping/>
+  </p:clrMapOvr>
+</p:sld>
+</file>
+
+<file path=ppt/slides/slide9.xml><?xml version="1.0" encoding="utf-8"?>
+<p:sld xmlns:a="http://schemas.openxmlformats.org/drawingml/2006/main" xmlns:p="http://schemas.openxmlformats.org/presentationml/2006/main" xmlns:r="http://schemas.openxmlformats.org/officeDocument/2006/relationships">
+  <p:cSld>
+    <p:spTree>
+      <p:nvGrpSpPr>
+        <p:cNvPr id="1" name=""/>
+        <p:cNvGrpSpPr/>
+        <p:nvPr/>
+      </p:nvGrpSpPr>
+      <p:grpSpPr/>
+      <p:sp>
+        <p:nvSpPr>
+          <p:cNvPr id="2" name="TextBox 1"/>
+          <p:cNvSpPr txBox="1"/>
+          <p:nvPr/>
+        </p:nvSpPr>
+        <p:spPr>
+          <a:xfrm>
+            <a:off x="457200" y="274320"/>
+            <a:ext cx="11247120" cy="640080"/>
+          </a:xfrm>
+          <a:prstGeom prst="rect">
+            <a:avLst/>
+          </a:prstGeom>
+          <a:noFill/>
+        </p:spPr>
+        <p:txBody>
+          <a:bodyPr wrap="none">
+            <a:spAutoFit/>
+          </a:bodyPr>
+          <a:lstStyle/>
+          <a:p>
+            <a:r>
+              <a:rPr sz="2600" b="1">
+                <a:solidFill>
+                  <a:srgbClr val="1D2330"/>
+                </a:solidFill>
+                <a:latin typeface="Calibri"/>
+              </a:rPr>
+              <a:t>Casos de prueba que cubren cada requisito</a:t>
+            </a:r>
+          </a:p>
+          <a:p>
+            <a:r>
+              <a:rPr sz="1400">
+                <a:solidFill>
+                  <a:srgbClr val="5A6270"/>
+                </a:solidFill>
+                <a:latin typeface="Calibri"/>
+              </a:rPr>
+              <a:t>Un caso puede cubrir más de un requisito: CP-07 cubre RF-01, RF-02 y RF-03</a:t>
+            </a:r>
+          </a:p>
+        </p:txBody>
+      </p:sp>
+      <p:graphicFrame>
+        <p:nvGraphicFramePr>
+          <p:cNvPr id="3" name="Chart 2"/>
+          <p:cNvGraphicFramePr>
+            <a:graphicFrameLocks noGrp="1"/>
+          </p:cNvGraphicFramePr>
+          <p:nvPr/>
+        </p:nvGraphicFramePr>
+        <p:xfrm>
+          <a:off x="731520" y="1371600"/>
+          <a:ext cx="10698480" cy="4846320"/>
+        </p:xfrm>
+        <a:graphic>
+          <a:graphicData uri="http://schemas.openxmlformats.org/drawingml/2006/chart">
+            <c:chart xmlns:c="http://schemas.openxmlformats.org/drawingml/2006/chart" r:id="rId2"/>
+          </a:graphicData>
+        </a:graphic>
+      </p:graphicFrame>
+      <p:sp>
+        <p:nvSpPr>
+          <p:cNvPr id="4" name="TextBox 3"/>
+          <p:cNvSpPr txBox="1"/>
+          <p:nvPr/>
+        </p:nvSpPr>
+        <p:spPr>
+          <a:xfrm>
+            <a:off x="731520" y="6263640"/>
+            <a:ext cx="10698480" cy="365760"/>
+          </a:xfrm>
+          <a:prstGeom prst="rect">
+            <a:avLst/>
+          </a:prstGeom>
+          <a:noFill/>
+        </p:spPr>
+        <p:txBody>
+          <a:bodyPr wrap="square">
+            <a:spAutoFit/>
+          </a:bodyPr>
+          <a:lstStyle/>
+          <a:p>
+            <a:r>
+              <a:rPr sz="1000" i="0">
+                <a:solidFill>
+                  <a:srgbClr val="5A6270"/>
+                </a:solidFill>
+                <a:latin typeface="Calibri"/>
+              </a:rPr>
+              <a:t>RF-01: CP-01, CP-02, CP-07 y CP-12  ·  RF-02: CP-05, CP-07, CP-10 y CP-11  ·  RF-03: CP-03, CP-04, CP-05, CP-06, CP-07 y CP-08  ·  RF-04: CP-10 y CP-13  ·  RF-05: CP-09</a:t>
             </a:r>
           </a:p>
         </p:txBody>

</xml_diff>

<commit_message>
docs: segunda parte con 15 casos (CP-14 consulta existente y CP-15 proceso completo), gráficas y capturas actualizadas
</commit_message>
<xml_diff>
--- a/docs/Segunda parte/Diagramas - Segunda parte.pptx
+++ b/docs/Segunda parte/Diagramas - Segunda parte.pptx
@@ -174,10 +174,10 @@
                   <c:v>1.0</c:v>
                 </c:pt>
                 <c:pt idx="1">
-                  <c:v>0.7692307692307693</c:v>
+                  <c:v>0.7333333333333333</c:v>
                 </c:pt>
                 <c:pt idx="2">
-                  <c:v>0.9230769230769231</c:v>
+                  <c:v>0.8666666666666667</c:v>
                 </c:pt>
                 <c:pt idx="3">
                   <c:v>1.0</c:v>
@@ -343,13 +343,13 @@
                   <c:v>5</c:v>
                 </c:pt>
                 <c:pt idx="1">
-                  <c:v>3</c:v>
+                  <c:v>4</c:v>
                 </c:pt>
                 <c:pt idx="2">
                   <c:v>3</c:v>
                 </c:pt>
                 <c:pt idx="3">
-                  <c:v>2</c:v>
+                  <c:v>3</c:v>
                 </c:pt>
               </c:numCache>
             </c:numRef>
@@ -511,19 +511,19 @@
                 <c:formatCode>0</c:formatCode>
                 <c:ptCount val="5"/>
                 <c:pt idx="0">
-                  <c:v>4</c:v>
+                  <c:v>5</c:v>
                 </c:pt>
                 <c:pt idx="1">
-                  <c:v>4</c:v>
+                  <c:v>6</c:v>
                 </c:pt>
                 <c:pt idx="2">
-                  <c:v>6</c:v>
+                  <c:v>7</c:v>
                 </c:pt>
                 <c:pt idx="3">
-                  <c:v>2</c:v>
+                  <c:v>3</c:v>
                 </c:pt>
                 <c:pt idx="4">
-                  <c:v>1</c:v>
+                  <c:v>2</c:v>
                 </c:pt>
               </c:numCache>
             </c:numRef>
@@ -682,16 +682,16 @@
                 <c:formatCode>0.000 "s"</c:formatCode>
                 <c:ptCount val="4"/>
                 <c:pt idx="0">
-                  <c:v>0.004</c:v>
+                  <c:v>0.005</c:v>
                 </c:pt>
                 <c:pt idx="1">
-                  <c:v>0.009</c:v>
+                  <c:v>0.014</c:v>
                 </c:pt>
                 <c:pt idx="2">
-                  <c:v>2.737</c:v>
+                  <c:v>2.626</c:v>
                 </c:pt>
                 <c:pt idx="3">
-                  <c:v>1.85</c:v>
+                  <c:v>2.612</c:v>
                 </c:pt>
               </c:numCache>
             </c:numRef>
@@ -3815,7 +3815,7 @@
                 </a:solidFill>
                 <a:latin typeface="Calibri"/>
               </a:rPr>
-              <a:t>13 casos automatizados con PHPUnit, una carpeta por nivel en tests/</a:t>
+              <a:t>15 casos automatizados con PHPUnit, una carpeta por nivel en tests/</a:t>
             </a:r>
           </a:p>
         </p:txBody>
@@ -3870,7 +3870,7 @@
                 </a:solidFill>
                 <a:latin typeface="Calibri"/>
               </a:rPr>
-              <a:t>Aceptación · CP-09 y CP-10</a:t>
+              <a:t>Aceptación · CP-09, CP-10 y CP-15</a:t>
             </a:r>
           </a:p>
           <a:p>
@@ -4004,7 +4004,7 @@
                 </a:solidFill>
                 <a:latin typeface="Calibri"/>
               </a:rPr>
-              <a:t>Integración · CP-05, CP-06 y CP-13</a:t>
+              <a:t>Integración · CP-05, CP-06, CP-13 y CP-14</a:t>
             </a:r>
           </a:p>
           <a:p>
@@ -4180,7 +4180,7 @@
                 </a:solidFill>
                 <a:latin typeface="Calibri"/>
               </a:rPr>
-              <a:t>Suma del tiempo de los casos de cada nivel · total de la ronda: 4.600 s</a:t>
+              <a:t>Suma del tiempo de los casos de cada nivel · total de la ronda: 5.257 s</a:t>
             </a:r>
           </a:p>
         </p:txBody>
@@ -6262,7 +6262,7 @@
         </p:nvGraphicFramePr>
         <p:xfrm>
           <a:off x="548640" y="1463040"/>
-          <a:ext cx="11064228" cy="3017520"/>
+          <a:ext cx="11064240" cy="3017520"/>
         </p:xfrm>
         <a:graphic>
           <a:graphicData uri="http://schemas.openxmlformats.org/drawingml/2006/table">
@@ -6272,19 +6272,21 @@
               </a:tblPr>
               <a:tblGrid>
                 <a:gridCol w="3291840"/>
-                <a:gridCol w="597876"/>
-                <a:gridCol w="597876"/>
-                <a:gridCol w="597876"/>
-                <a:gridCol w="597876"/>
-                <a:gridCol w="597876"/>
-                <a:gridCol w="597876"/>
-                <a:gridCol w="597876"/>
-                <a:gridCol w="597876"/>
-                <a:gridCol w="597876"/>
-                <a:gridCol w="597876"/>
-                <a:gridCol w="597876"/>
-                <a:gridCol w="597876"/>
-                <a:gridCol w="597876"/>
+                <a:gridCol w="518160"/>
+                <a:gridCol w="518160"/>
+                <a:gridCol w="518160"/>
+                <a:gridCol w="518160"/>
+                <a:gridCol w="518160"/>
+                <a:gridCol w="518160"/>
+                <a:gridCol w="518160"/>
+                <a:gridCol w="518160"/>
+                <a:gridCol w="518160"/>
+                <a:gridCol w="518160"/>
+                <a:gridCol w="518160"/>
+                <a:gridCol w="518160"/>
+                <a:gridCol w="518160"/>
+                <a:gridCol w="518160"/>
+                <a:gridCol w="518160"/>
               </a:tblGrid>
               <a:tr h="502920">
                 <a:tc>
@@ -6609,6 +6611,52 @@
                     </a:solidFill>
                   </a:tcPr>
                 </a:tc>
+                <a:tc>
+                  <a:txBody>
+                    <a:bodyPr/>
+                    <a:lstStyle/>
+                    <a:p>
+                      <a:pPr algn="ctr"/>
+                      <a:r>
+                        <a:rPr sz="1300" b="1">
+                          <a:solidFill>
+                            <a:srgbClr val="FFFFFF"/>
+                          </a:solidFill>
+                          <a:latin typeface="Calibri"/>
+                        </a:rPr>
+                        <a:t>CP-14</a:t>
+                      </a:r>
+                    </a:p>
+                  </a:txBody>
+                  <a:tcPr marL="54864" marR="54864" marT="27432" marB="27432" anchor="ctr">
+                    <a:solidFill>
+                      <a:srgbClr val="1F4E8C"/>
+                    </a:solidFill>
+                  </a:tcPr>
+                </a:tc>
+                <a:tc>
+                  <a:txBody>
+                    <a:bodyPr/>
+                    <a:lstStyle/>
+                    <a:p>
+                      <a:pPr algn="ctr"/>
+                      <a:r>
+                        <a:rPr sz="1300" b="1">
+                          <a:solidFill>
+                            <a:srgbClr val="FFFFFF"/>
+                          </a:solidFill>
+                          <a:latin typeface="Calibri"/>
+                        </a:rPr>
+                        <a:t>CP-15</a:t>
+                      </a:r>
+                    </a:p>
+                  </a:txBody>
+                  <a:tcPr marL="54864" marR="54864" marT="27432" marB="27432" anchor="ctr">
+                    <a:solidFill>
+                      <a:srgbClr val="1F4E8C"/>
+                    </a:solidFill>
+                  </a:tcPr>
+                </a:tc>
               </a:tr>
               <a:tr h="502920">
                 <a:tc>
@@ -6933,6 +6981,52 @@
                     </a:solidFill>
                   </a:tcPr>
                 </a:tc>
+                <a:tc>
+                  <a:txBody>
+                    <a:bodyPr/>
+                    <a:lstStyle/>
+                    <a:p>
+                      <a:pPr algn="ctr"/>
+                      <a:r>
+                        <a:rPr sz="1300" b="0">
+                          <a:solidFill>
+                            <a:srgbClr val="1D2330"/>
+                          </a:solidFill>
+                          <a:latin typeface="Calibri"/>
+                        </a:rPr>
+                        <a:t/>
+                      </a:r>
+                    </a:p>
+                  </a:txBody>
+                  <a:tcPr marL="54864" marR="54864" marT="27432" marB="27432" anchor="ctr">
+                    <a:solidFill>
+                      <a:srgbClr val="FFFFFF"/>
+                    </a:solidFill>
+                  </a:tcPr>
+                </a:tc>
+                <a:tc>
+                  <a:txBody>
+                    <a:bodyPr/>
+                    <a:lstStyle/>
+                    <a:p>
+                      <a:pPr algn="ctr"/>
+                      <a:r>
+                        <a:rPr sz="1300" b="0">
+                          <a:solidFill>
+                            <a:srgbClr val="1D2330"/>
+                          </a:solidFill>
+                          <a:latin typeface="Calibri"/>
+                        </a:rPr>
+                        <a:t>✔</a:t>
+                      </a:r>
+                    </a:p>
+                  </a:txBody>
+                  <a:tcPr marL="54864" marR="54864" marT="27432" marB="27432" anchor="ctr">
+                    <a:solidFill>
+                      <a:srgbClr val="E8F0FB"/>
+                    </a:solidFill>
+                  </a:tcPr>
+                </a:tc>
               </a:tr>
               <a:tr h="502920">
                 <a:tc>
@@ -7257,6 +7351,52 @@
                     </a:solidFill>
                   </a:tcPr>
                 </a:tc>
+                <a:tc>
+                  <a:txBody>
+                    <a:bodyPr/>
+                    <a:lstStyle/>
+                    <a:p>
+                      <a:pPr algn="ctr"/>
+                      <a:r>
+                        <a:rPr sz="1300" b="0">
+                          <a:solidFill>
+                            <a:srgbClr val="1D2330"/>
+                          </a:solidFill>
+                          <a:latin typeface="Calibri"/>
+                        </a:rPr>
+                        <a:t>✔</a:t>
+                      </a:r>
+                    </a:p>
+                  </a:txBody>
+                  <a:tcPr marL="54864" marR="54864" marT="27432" marB="27432" anchor="ctr">
+                    <a:solidFill>
+                      <a:srgbClr val="E8F0FB"/>
+                    </a:solidFill>
+                  </a:tcPr>
+                </a:tc>
+                <a:tc>
+                  <a:txBody>
+                    <a:bodyPr/>
+                    <a:lstStyle/>
+                    <a:p>
+                      <a:pPr algn="ctr"/>
+                      <a:r>
+                        <a:rPr sz="1300" b="0">
+                          <a:solidFill>
+                            <a:srgbClr val="1D2330"/>
+                          </a:solidFill>
+                          <a:latin typeface="Calibri"/>
+                        </a:rPr>
+                        <a:t>✔</a:t>
+                      </a:r>
+                    </a:p>
+                  </a:txBody>
+                  <a:tcPr marL="54864" marR="54864" marT="27432" marB="27432" anchor="ctr">
+                    <a:solidFill>
+                      <a:srgbClr val="E8F0FB"/>
+                    </a:solidFill>
+                  </a:tcPr>
+                </a:tc>
               </a:tr>
               <a:tr h="502920">
                 <a:tc>
@@ -7581,6 +7721,52 @@
                     </a:solidFill>
                   </a:tcPr>
                 </a:tc>
+                <a:tc>
+                  <a:txBody>
+                    <a:bodyPr/>
+                    <a:lstStyle/>
+                    <a:p>
+                      <a:pPr algn="ctr"/>
+                      <a:r>
+                        <a:rPr sz="1300" b="0">
+                          <a:solidFill>
+                            <a:srgbClr val="1D2330"/>
+                          </a:solidFill>
+                          <a:latin typeface="Calibri"/>
+                        </a:rPr>
+                        <a:t/>
+                      </a:r>
+                    </a:p>
+                  </a:txBody>
+                  <a:tcPr marL="54864" marR="54864" marT="27432" marB="27432" anchor="ctr">
+                    <a:solidFill>
+                      <a:srgbClr val="FFFFFF"/>
+                    </a:solidFill>
+                  </a:tcPr>
+                </a:tc>
+                <a:tc>
+                  <a:txBody>
+                    <a:bodyPr/>
+                    <a:lstStyle/>
+                    <a:p>
+                      <a:pPr algn="ctr"/>
+                      <a:r>
+                        <a:rPr sz="1300" b="0">
+                          <a:solidFill>
+                            <a:srgbClr val="1D2330"/>
+                          </a:solidFill>
+                          <a:latin typeface="Calibri"/>
+                        </a:rPr>
+                        <a:t>✔</a:t>
+                      </a:r>
+                    </a:p>
+                  </a:txBody>
+                  <a:tcPr marL="54864" marR="54864" marT="27432" marB="27432" anchor="ctr">
+                    <a:solidFill>
+                      <a:srgbClr val="E8F0FB"/>
+                    </a:solidFill>
+                  </a:tcPr>
+                </a:tc>
               </a:tr>
               <a:tr h="502920">
                 <a:tc>
@@ -7905,6 +8091,52 @@
                     </a:solidFill>
                   </a:tcPr>
                 </a:tc>
+                <a:tc>
+                  <a:txBody>
+                    <a:bodyPr/>
+                    <a:lstStyle/>
+                    <a:p>
+                      <a:pPr algn="ctr"/>
+                      <a:r>
+                        <a:rPr sz="1300" b="0">
+                          <a:solidFill>
+                            <a:srgbClr val="1D2330"/>
+                          </a:solidFill>
+                          <a:latin typeface="Calibri"/>
+                        </a:rPr>
+                        <a:t/>
+                      </a:r>
+                    </a:p>
+                  </a:txBody>
+                  <a:tcPr marL="54864" marR="54864" marT="27432" marB="27432" anchor="ctr">
+                    <a:solidFill>
+                      <a:srgbClr val="F4F5F7"/>
+                    </a:solidFill>
+                  </a:tcPr>
+                </a:tc>
+                <a:tc>
+                  <a:txBody>
+                    <a:bodyPr/>
+                    <a:lstStyle/>
+                    <a:p>
+                      <a:pPr algn="ctr"/>
+                      <a:r>
+                        <a:rPr sz="1300" b="0">
+                          <a:solidFill>
+                            <a:srgbClr val="1D2330"/>
+                          </a:solidFill>
+                          <a:latin typeface="Calibri"/>
+                        </a:rPr>
+                        <a:t>✔</a:t>
+                      </a:r>
+                    </a:p>
+                  </a:txBody>
+                  <a:tcPr marL="54864" marR="54864" marT="27432" marB="27432" anchor="ctr">
+                    <a:solidFill>
+                      <a:srgbClr val="E8F0FB"/>
+                    </a:solidFill>
+                  </a:tcPr>
+                </a:tc>
               </a:tr>
               <a:tr h="502920">
                 <a:tc>
@@ -8226,6 +8458,52 @@
                   <a:tcPr marL="54864" marR="54864" marT="27432" marB="27432" anchor="ctr">
                     <a:solidFill>
                       <a:srgbClr val="FFFFFF"/>
+                    </a:solidFill>
+                  </a:tcPr>
+                </a:tc>
+                <a:tc>
+                  <a:txBody>
+                    <a:bodyPr/>
+                    <a:lstStyle/>
+                    <a:p>
+                      <a:pPr algn="ctr"/>
+                      <a:r>
+                        <a:rPr sz="1300" b="0">
+                          <a:solidFill>
+                            <a:srgbClr val="1D2330"/>
+                          </a:solidFill>
+                          <a:latin typeface="Calibri"/>
+                        </a:rPr>
+                        <a:t/>
+                      </a:r>
+                    </a:p>
+                  </a:txBody>
+                  <a:tcPr marL="54864" marR="54864" marT="27432" marB="27432" anchor="ctr">
+                    <a:solidFill>
+                      <a:srgbClr val="FFFFFF"/>
+                    </a:solidFill>
+                  </a:tcPr>
+                </a:tc>
+                <a:tc>
+                  <a:txBody>
+                    <a:bodyPr/>
+                    <a:lstStyle/>
+                    <a:p>
+                      <a:pPr algn="ctr"/>
+                      <a:r>
+                        <a:rPr sz="1300" b="0">
+                          <a:solidFill>
+                            <a:srgbClr val="1D2330"/>
+                          </a:solidFill>
+                          <a:latin typeface="Calibri"/>
+                        </a:rPr>
+                        <a:t>✔</a:t>
+                      </a:r>
+                    </a:p>
+                  </a:txBody>
+                  <a:tcPr marL="54864" marR="54864" marT="27432" marB="27432" anchor="ctr">
+                    <a:solidFill>
+                      <a:srgbClr val="E8F0FB"/>
                     </a:solidFill>
                   </a:tcPr>
                 </a:tc>
@@ -8263,7 +8541,7 @@
                 </a:solidFill>
                 <a:latin typeface="Calibri"/>
               </a:rPr>
-              <a:t>Unitaria: CP-01, CP-02, CP-03, CP-04 y CP-12 · Integración: CP-05, CP-06 y CP-13 · Sistema: CP-07, CP-08 y CP-11 · Aceptación: CP-09 y CP-10</a:t>
+              <a:t>Unitaria: CP-01, CP-02, CP-03, CP-04 y CP-12 · Integración: CP-05, CP-06, CP-13 y CP-14 · Sistema: CP-07, CP-08 y CP-11 · Aceptación: CP-09, CP-10 y CP-15</a:t>
             </a:r>
           </a:p>
         </p:txBody>
@@ -8378,7 +8656,7 @@
                 </a:solidFill>
                 <a:latin typeface="Calibri"/>
               </a:rPr>
-              <a:t>Ronda 1 · código actual: 13 de 13  ·  Ronda 2 · con DEF-01: 10 de 13  ·  Ronda 3 · con DEF-02: 12 de 13  ·  Ronda 4 · código corregido: 13 de 13</a:t>
+              <a:t>Ronda 1 · código actual: 15 de 15  ·  Ronda 2 · con DEF-01: 11 de 15  ·  Ronda 3 · con DEF-02: 13 de 15  ·  Ronda 4 · código corregido: 15 de 15</a:t>
             </a:r>
           </a:p>
         </p:txBody>
@@ -8765,7 +9043,7 @@
                 </a:solidFill>
                 <a:latin typeface="Calibri"/>
               </a:rPr>
-              <a:t>los 13 casos por niveles</a:t>
+              <a:t>los 15 casos por niveles</a:t>
             </a:r>
           </a:p>
         </p:txBody>
@@ -10474,7 +10752,7 @@
                 </a:solidFill>
                 <a:latin typeface="Calibri"/>
               </a:rPr>
-              <a:t>CP-05, CP-06 y CP-13</a:t>
+              <a:t>CP-05, CP-06, CP-13 y CP-14</a:t>
             </a:r>
           </a:p>
           <a:p>
@@ -10636,7 +10914,7 @@
                 </a:solidFill>
                 <a:latin typeface="Calibri"/>
               </a:rPr>
-              <a:t>CP-09 y CP-10</a:t>
+              <a:t>CP-09, CP-10 y CP-15</a:t>
             </a:r>
           </a:p>
           <a:p>
@@ -11526,7 +11804,7 @@
                 </a:solidFill>
                 <a:latin typeface="Calibri"/>
               </a:rPr>
-              <a:t>13 casos en total; cada nivel tiene su propia suite de PHPUnit</a:t>
+              <a:t>15 casos en total; cada nivel tiene su propia suite de PHPUnit</a:t>
             </a:r>
           </a:p>
         </p:txBody>
@@ -11578,7 +11856,7 @@
                 </a:solidFill>
                 <a:latin typeface="Calibri"/>
               </a:rPr>
-              <a:t>Unitaria: CP-01, CP-02, CP-03, CP-04 y CP-12  ·  Integración: CP-05, CP-06 y CP-13  ·  Sistema: CP-07, CP-08 y CP-11  ·  Aceptación: CP-09 y CP-10</a:t>
+              <a:t>Unitaria: CP-01, CP-02, CP-03, CP-04 y CP-12  ·  Integración: CP-05, CP-06, CP-13 y CP-14  ·  Sistema: CP-07, CP-08 y CP-11  ·  Aceptación: CP-09, CP-10 y CP-15</a:t>
             </a:r>
           </a:p>
         </p:txBody>
@@ -11641,7 +11919,7 @@
                 </a:solidFill>
                 <a:latin typeface="Calibri"/>
               </a:rPr>
-              <a:t>Un caso puede cubrir más de un requisito: CP-07 cubre RF-01, RF-02 y RF-03</a:t>
+              <a:t>Un caso puede cubrir más de un requisito: CP-15 recorre los cinco, de RF-01 a RF-05</a:t>
             </a:r>
           </a:p>
         </p:txBody>
@@ -11693,7 +11971,7 @@
                 </a:solidFill>
                 <a:latin typeface="Calibri"/>
               </a:rPr>
-              <a:t>RF-01: CP-01, CP-02, CP-07 y CP-12  ·  RF-02: CP-05, CP-07, CP-10 y CP-11  ·  RF-03: CP-03, CP-04, CP-05, CP-06, CP-07 y CP-08  ·  RF-04: CP-10 y CP-13  ·  RF-05: CP-09</a:t>
+              <a:t>RF-01: CP-01, CP-02, CP-07, CP-12 y CP-15  ·  RF-02: CP-05, CP-07, CP-10, CP-11, CP-14 y CP-15  ·  RF-03: CP-03, CP-04, CP-05, CP-06, CP-07, CP-08 y CP-15  ·  RF-04: CP-10, CP-13 y CP-15  ·  RF-05: CP-09 y CP-15</a:t>
             </a:r>
           </a:p>
         </p:txBody>

</xml_diff>

<commit_message>
Quitar rutas locales de la evidencia y actualizar diagramas
- scripts/lib.php: la salida de PHPUnit y los JUnit se guardan con rutas
  relativas a la raíz del proyecto (sin la carpeta local de quien los genera).
- evidencias/: se quitó la ruta local de los JUnit y las salidas de consola;
  tiempos, fechas y resultados no cambian (siguen siendo los del commit 7108e1e).
- docs/Segunda parte: diagramas sin la nota de texto al pie de cada imagen.
</commit_message>
<xml_diff>
--- a/docs/Segunda parte/Diagramas - Segunda parte.pptx
+++ b/docs/Segunda parte/Diagramas - Segunda parte.pptx
@@ -4088,40 +4088,6 @@
           </a:p>
         </p:txBody>
       </p:sp>
-      <p:sp>
-        <p:nvSpPr>
-          <p:cNvPr id="7" name="TextBox 6"/>
-          <p:cNvSpPr txBox="1"/>
-          <p:nvPr/>
-        </p:nvSpPr>
-        <p:spPr>
-          <a:xfrm>
-            <a:off x="548640" y="6263640"/>
-            <a:ext cx="10972800" cy="365760"/>
-          </a:xfrm>
-          <a:prstGeom prst="rect">
-            <a:avLst/>
-          </a:prstGeom>
-          <a:noFill/>
-        </p:spPr>
-        <p:txBody>
-          <a:bodyPr wrap="square">
-            <a:spAutoFit/>
-          </a:bodyPr>
-          <a:lstStyle/>
-          <a:p>
-            <a:r>
-              <a:rPr sz="1100" i="0">
-                <a:solidFill>
-                  <a:srgbClr val="5A6270"/>
-                </a:solidFill>
-                <a:latin typeface="Calibri"/>
-              </a:rPr>
-              <a:t>Más arriba: más cerca de lo que usa la cliente y más lento (≈ 0.9 s por caso). Más abajo: más rápido (milisegundos) y más preciso para ubicar el error.</a:t>
-            </a:r>
-          </a:p>
-        </p:txBody>
-      </p:sp>
     </p:spTree>
   </p:cSld>
   <p:clrMapOvr>
@@ -4203,40 +4169,6 @@
           </a:graphicData>
         </a:graphic>
       </p:graphicFrame>
-      <p:sp>
-        <p:nvSpPr>
-          <p:cNvPr id="4" name="TextBox 3"/>
-          <p:cNvSpPr txBox="1"/>
-          <p:nvPr/>
-        </p:nvSpPr>
-        <p:spPr>
-          <a:xfrm>
-            <a:off x="731520" y="6263640"/>
-            <a:ext cx="10698480" cy="365760"/>
-          </a:xfrm>
-          <a:prstGeom prst="rect">
-            <a:avLst/>
-          </a:prstGeom>
-          <a:noFill/>
-        </p:spPr>
-        <p:txBody>
-          <a:bodyPr wrap="square">
-            <a:spAutoFit/>
-          </a:bodyPr>
-          <a:lstStyle/>
-          <a:p>
-            <a:r>
-              <a:rPr sz="1100" i="0">
-                <a:solidFill>
-                  <a:srgbClr val="5A6270"/>
-                </a:solidFill>
-                <a:latin typeface="Calibri"/>
-              </a:rPr>
-              <a:t>Los casos de sistema y aceptación levantan su propio servidor php -S, por eso tardan cerca de 0.9 s cada uno; los unitarios y de integración tardan milisegundos.</a:t>
-            </a:r>
-          </a:p>
-        </p:txBody>
-      </p:sp>
     </p:spTree>
   </p:cSld>
   <p:clrMapOvr>
@@ -8627,40 +8559,6 @@
           </a:graphicData>
         </a:graphic>
       </p:graphicFrame>
-      <p:sp>
-        <p:nvSpPr>
-          <p:cNvPr id="4" name="TextBox 3"/>
-          <p:cNvSpPr txBox="1"/>
-          <p:nvPr/>
-        </p:nvSpPr>
-        <p:spPr>
-          <a:xfrm>
-            <a:off x="731520" y="6263640"/>
-            <a:ext cx="10698480" cy="365760"/>
-          </a:xfrm>
-          <a:prstGeom prst="rect">
-            <a:avLst/>
-          </a:prstGeom>
-          <a:noFill/>
-        </p:spPr>
-        <p:txBody>
-          <a:bodyPr wrap="square">
-            <a:spAutoFit/>
-          </a:bodyPr>
-          <a:lstStyle/>
-          <a:p>
-            <a:r>
-              <a:rPr sz="1100" i="0">
-                <a:solidFill>
-                  <a:srgbClr val="5A6270"/>
-                </a:solidFill>
-                <a:latin typeface="Calibri"/>
-              </a:rPr>
-              <a:t>Ronda 1 · código actual: 15 de 15  ·  Ronda 2 · con DEF-01: 11 de 15  ·  Ronda 3 · con DEF-02: 13 de 15  ·  Ronda 4 · código corregido: 15 de 15</a:t>
-            </a:r>
-          </a:p>
-        </p:txBody>
-      </p:sp>
     </p:spTree>
   </p:cSld>
   <p:clrMapOvr>
@@ -9471,40 +9369,6 @@
                 <a:latin typeface="Calibri"/>
               </a:rPr>
               <a:t>si algún caso falla, se regresa a corrección</a:t>
-            </a:r>
-          </a:p>
-        </p:txBody>
-      </p:sp>
-      <p:sp>
-        <p:nvSpPr>
-          <p:cNvPr id="16" name="TextBox 15"/>
-          <p:cNvSpPr txBox="1"/>
-          <p:nvPr/>
-        </p:nvSpPr>
-        <p:spPr>
-          <a:xfrm>
-            <a:off x="548640" y="5852160"/>
-            <a:ext cx="11155680" cy="548640"/>
-          </a:xfrm>
-          <a:prstGeom prst="rect">
-            <a:avLst/>
-          </a:prstGeom>
-          <a:noFill/>
-        </p:spPr>
-        <p:txBody>
-          <a:bodyPr wrap="square">
-            <a:spAutoFit/>
-          </a:bodyPr>
-          <a:lstStyle/>
-          <a:p>
-            <a:r>
-              <a:rPr sz="1200" i="0">
-                <a:solidFill>
-                  <a:srgbClr val="5A6270"/>
-                </a:solidFill>
-                <a:latin typeface="Calibri"/>
-              </a:rPr>
-              <a:t>Regresión nocturna: el CI repite la suite completa cada día a la 01:00 aunque no haya cambios.</a:t>
             </a:r>
           </a:p>
         </p:txBody>
@@ -10405,40 +10269,6 @@
           </a:p>
         </p:txBody>
       </p:sp>
-      <p:sp>
-        <p:nvSpPr>
-          <p:cNvPr id="18" name="TextBox 17"/>
-          <p:cNvSpPr txBox="1"/>
-          <p:nvPr/>
-        </p:nvSpPr>
-        <p:spPr>
-          <a:xfrm>
-            <a:off x="457200" y="5989320"/>
-            <a:ext cx="11247120" cy="548640"/>
-          </a:xfrm>
-          <a:prstGeom prst="rect">
-            <a:avLst/>
-          </a:prstGeom>
-          <a:noFill/>
-        </p:spPr>
-        <p:txBody>
-          <a:bodyPr wrap="square">
-            <a:spAutoFit/>
-          </a:bodyPr>
-          <a:lstStyle/>
-          <a:p>
-            <a:r>
-              <a:rPr sz="1200" i="0">
-                <a:solidFill>
-                  <a:srgbClr val="5A6270"/>
-                </a:solidFill>
-                <a:latin typeface="Calibri"/>
-              </a:rPr>
-              <a:t>Archivo del flujo: .github/workflows/ci.yml · se ejecuta en cada push, en cada Pull Request a main o develop y cada noche a la 01:00</a:t>
-            </a:r>
-          </a:p>
-        </p:txBody>
-      </p:sp>
     </p:spTree>
   </p:cSld>
   <p:clrMapOvr>
@@ -11708,40 +11538,6 @@
                 <a:latin typeface="Calibri"/>
               </a:rPr>
               <a:t>y el Pull Request se bloquea.</a:t>
-            </a:r>
-          </a:p>
-        </p:txBody>
-      </p:sp>
-      <p:sp>
-        <p:nvSpPr>
-          <p:cNvPr id="24" name="TextBox 23"/>
-          <p:cNvSpPr txBox="1"/>
-          <p:nvPr/>
-        </p:nvSpPr>
-        <p:spPr>
-          <a:xfrm>
-            <a:off x="365760" y="5852160"/>
-            <a:ext cx="11430000" cy="548640"/>
-          </a:xfrm>
-          <a:prstGeom prst="rect">
-            <a:avLst/>
-          </a:prstGeom>
-          <a:noFill/>
-        </p:spPr>
-        <p:txBody>
-          <a:bodyPr wrap="square">
-            <a:spAutoFit/>
-          </a:bodyPr>
-          <a:lstStyle/>
-          <a:p>
-            <a:r>
-              <a:rPr sz="1100" i="0">
-                <a:solidFill>
-                  <a:srgbClr val="5A6270"/>
-                </a:solidFill>
-                <a:latin typeface="Calibri"/>
-              </a:rPr>
-              <a:t>concurrency: un push nuevo en la misma rama cancela la ejecución anterior · caché de Composer por versión de PHP · protección de ramas: main y develop solo aceptan PR con todos los checks en verde</a:t>
             </a:r>
           </a:p>
         </p:txBody>
@@ -11827,40 +11623,6 @@
           </a:graphicData>
         </a:graphic>
       </p:graphicFrame>
-      <p:sp>
-        <p:nvSpPr>
-          <p:cNvPr id="4" name="TextBox 3"/>
-          <p:cNvSpPr txBox="1"/>
-          <p:nvPr/>
-        </p:nvSpPr>
-        <p:spPr>
-          <a:xfrm>
-            <a:off x="731520" y="6263640"/>
-            <a:ext cx="10698480" cy="365760"/>
-          </a:xfrm>
-          <a:prstGeom prst="rect">
-            <a:avLst/>
-          </a:prstGeom>
-          <a:noFill/>
-        </p:spPr>
-        <p:txBody>
-          <a:bodyPr wrap="square">
-            <a:spAutoFit/>
-          </a:bodyPr>
-          <a:lstStyle/>
-          <a:p>
-            <a:r>
-              <a:rPr sz="1100" i="0">
-                <a:solidFill>
-                  <a:srgbClr val="5A6270"/>
-                </a:solidFill>
-                <a:latin typeface="Calibri"/>
-              </a:rPr>
-              <a:t>Unitaria: CP-01, CP-02, CP-03, CP-04 y CP-12  ·  Integración: CP-05, CP-06, CP-13 y CP-14  ·  Sistema: CP-07, CP-08 y CP-11  ·  Aceptación: CP-09, CP-10 y CP-15</a:t>
-            </a:r>
-          </a:p>
-        </p:txBody>
-      </p:sp>
     </p:spTree>
   </p:cSld>
   <p:clrMapOvr>
@@ -11942,40 +11704,6 @@
           </a:graphicData>
         </a:graphic>
       </p:graphicFrame>
-      <p:sp>
-        <p:nvSpPr>
-          <p:cNvPr id="4" name="TextBox 3"/>
-          <p:cNvSpPr txBox="1"/>
-          <p:nvPr/>
-        </p:nvSpPr>
-        <p:spPr>
-          <a:xfrm>
-            <a:off x="731520" y="6263640"/>
-            <a:ext cx="10698480" cy="365760"/>
-          </a:xfrm>
-          <a:prstGeom prst="rect">
-            <a:avLst/>
-          </a:prstGeom>
-          <a:noFill/>
-        </p:spPr>
-        <p:txBody>
-          <a:bodyPr wrap="square">
-            <a:spAutoFit/>
-          </a:bodyPr>
-          <a:lstStyle/>
-          <a:p>
-            <a:r>
-              <a:rPr sz="1000" i="0">
-                <a:solidFill>
-                  <a:srgbClr val="5A6270"/>
-                </a:solidFill>
-                <a:latin typeface="Calibri"/>
-              </a:rPr>
-              <a:t>RF-01: CP-01, CP-02, CP-07, CP-12 y CP-15  ·  RF-02: CP-05, CP-07, CP-10, CP-11, CP-14 y CP-15  ·  RF-03: CP-03, CP-04, CP-05, CP-06, CP-07, CP-08 y CP-15  ·  RF-04: CP-10, CP-13 y CP-15  ·  RF-05: CP-09 y CP-15</a:t>
-            </a:r>
-          </a:p>
-        </p:txBody>
-      </p:sp>
     </p:spTree>
   </p:cSld>
   <p:clrMapOvr>

</xml_diff>